<commit_message>
feat: 新增 Google Drive 自動備份 (Step 4.5)
</commit_message>
<xml_diff>
--- a/weekly-ppt/ecoco_週報_第24週_0608-0614.pptx
+++ b/weekly-ppt/ecoco_週報_第24週_0608-0614.pptx
@@ -4,14 +4,14 @@
   <p:sldMasterIdLst>
     <p:sldMasterId id="2147483648" r:id="rId1"/>
   </p:sldMasterIdLst>
+  <p:notesMasterIdLst>
+    <p:notesMasterId r:id="rId4"/>
+  </p:notesMasterIdLst>
   <p:sldIdLst>
     <p:sldId id="256" r:id="rId2"/>
     <p:sldId id="257" r:id="rId3"/>
   </p:sldIdLst>
-  <p:notesMasterIdLst>
-    <p:notesMasterId r:id="rId4"/>
-  </p:notesMasterIdLst>
-  <p:sldSz cx="9144000" cy="5143500"/>
+  <p:sldSz cx="9144000" cy="5143500" type="screen16x9"/>
   <p:notesSz cx="5143500" cy="9144000"/>
   <p:defaultTextStyle>
     <a:lvl1pPr marL="0" algn="l" defTabSz="914400" rtl="0" eaLnBrk="1" latinLnBrk="0" hangingPunct="1">
@@ -105,13 +105,20 @@
       </a:defRPr>
     </a:lvl9pPr>
   </p:defaultTextStyle>
+  <p:extLst>
+    <p:ext uri="{EFAFB233-063F-42B5-8137-9DF3F51BA10A}">
+      <p15:sldGuideLst xmlns:p15="http://schemas.microsoft.com/office/powerpoint/2012/main"/>
+    </p:ext>
+  </p:extLst>
 </p:presentation>
 </file>
 
 <file path=ppt/charts/chart1.xml><?xml version="1.0" encoding="utf-8"?>
-<c:chartSpace xmlns:c="http://schemas.openxmlformats.org/drawingml/2006/chart" xmlns:a="http://schemas.openxmlformats.org/drawingml/2006/main" xmlns:r="http://schemas.openxmlformats.org/officeDocument/2006/relationships">
+<c:chartSpace xmlns:c="http://schemas.openxmlformats.org/drawingml/2006/chart" xmlns:a="http://schemas.openxmlformats.org/drawingml/2006/main" xmlns:r="http://schemas.openxmlformats.org/officeDocument/2006/relationships" xmlns:c16r2="http://schemas.microsoft.com/office/drawing/2015/06/chart">
   <c:date1904 val="0"/>
+  <c:lang val="zh-TW"/>
   <c:roundedCorners val="1"/>
+  <c:style val="2"/>
   <c:chart>
     <c:autoTitleDeleted val="1"/>
     <c:plotArea>
@@ -143,13 +150,7 @@
               <a:prstDash val="solid"/>
               <a:round/>
             </a:ln>
-            <a:effectLst>
-              <a:noneShdw sx="100000" sy="100000" kx="0" ky="0" algn="bl" blurRad="38100" rotWithShape="1" dist="23000" dir="5400000">
-                <a:srgbClr val="000000">
-                  <a:alpha val="35000"/>
-                </a:srgbClr>
-              </a:noneShdw>
-            </a:effectLst>
+            <a:effectLst/>
           </c:spPr>
           <c:dPt>
             <c:idx val="0"/>
@@ -158,14 +159,13 @@
               <a:solidFill>
                 <a:srgbClr val="060E9F"/>
               </a:solidFill>
-              <a:effectLst>
-                <a:noneShdw sx="100000" sy="100000" kx="0" ky="0" algn="bl" blurRad="38100" rotWithShape="1" dist="23000" dir="5400000">
-                  <a:srgbClr val="000000">
-                    <a:alpha val="35000"/>
-                  </a:srgbClr>
-                </a:noneShdw>
-              </a:effectLst>
+              <a:effectLst/>
             </c:spPr>
+            <c:extLst>
+              <c:ext xmlns:c16="http://schemas.microsoft.com/office/drawing/2014/chart" uri="{C3380CC4-5D6E-409C-BE32-E72D297353CC}">
+                <c16:uniqueId val="{00000001-67D2-4D8A-AC17-6D544EE1485B}"/>
+              </c:ext>
+            </c:extLst>
           </c:dPt>
           <c:dPt>
             <c:idx val="1"/>
@@ -174,14 +174,13 @@
               <a:solidFill>
                 <a:srgbClr val="FF5000"/>
               </a:solidFill>
-              <a:effectLst>
-                <a:noneShdw sx="100000" sy="100000" kx="0" ky="0" algn="bl" blurRad="38100" rotWithShape="1" dist="23000" dir="5400000">
-                  <a:srgbClr val="000000">
-                    <a:alpha val="35000"/>
-                  </a:srgbClr>
-                </a:noneShdw>
-              </a:effectLst>
+              <a:effectLst/>
             </c:spPr>
+            <c:extLst>
+              <c:ext xmlns:c16="http://schemas.microsoft.com/office/drawing/2014/chart" uri="{C3380CC4-5D6E-409C-BE32-E72D297353CC}">
+                <c16:uniqueId val="{00000003-67D2-4D8A-AC17-6D544EE1485B}"/>
+              </c:ext>
+            </c:extLst>
           </c:dPt>
           <c:dPt>
             <c:idx val="2"/>
@@ -190,14 +189,13 @@
               <a:solidFill>
                 <a:srgbClr val="0076A9"/>
               </a:solidFill>
-              <a:effectLst>
-                <a:noneShdw sx="100000" sy="100000" kx="0" ky="0" algn="bl" blurRad="38100" rotWithShape="1" dist="23000" dir="5400000">
-                  <a:srgbClr val="000000">
-                    <a:alpha val="35000"/>
-                  </a:srgbClr>
-                </a:noneShdw>
-              </a:effectLst>
+              <a:effectLst/>
             </c:spPr>
+            <c:extLst>
+              <c:ext xmlns:c16="http://schemas.microsoft.com/office/drawing/2014/chart" uri="{C3380CC4-5D6E-409C-BE32-E72D297353CC}">
+                <c16:uniqueId val="{00000005-67D2-4D8A-AC17-6D544EE1485B}"/>
+              </c:ext>
+            </c:extLst>
           </c:dPt>
           <c:dPt>
             <c:idx val="3"/>
@@ -206,14 +204,13 @@
               <a:solidFill>
                 <a:srgbClr val="FFCE00"/>
               </a:solidFill>
-              <a:effectLst>
-                <a:noneShdw sx="100000" sy="100000" kx="0" ky="0" algn="bl" blurRad="38100" rotWithShape="1" dist="23000" dir="5400000">
-                  <a:srgbClr val="000000">
-                    <a:alpha val="35000"/>
-                  </a:srgbClr>
-                </a:noneShdw>
-              </a:effectLst>
+              <a:effectLst/>
             </c:spPr>
+            <c:extLst>
+              <c:ext xmlns:c16="http://schemas.microsoft.com/office/drawing/2014/chart" uri="{C3380CC4-5D6E-409C-BE32-E72D297353CC}">
+                <c16:uniqueId val="{00000007-67D2-4D8A-AC17-6D544EE1485B}"/>
+              </c:ext>
+            </c:extLst>
           </c:dPt>
           <c:dPt>
             <c:idx val="4"/>
@@ -222,14 +219,13 @@
               <a:solidFill>
                 <a:srgbClr val="8EB8C9"/>
               </a:solidFill>
-              <a:effectLst>
-                <a:noneShdw sx="100000" sy="100000" kx="0" ky="0" algn="bl" blurRad="38100" rotWithShape="1" dist="23000" dir="5400000">
-                  <a:srgbClr val="000000">
-                    <a:alpha val="35000"/>
-                  </a:srgbClr>
-                </a:noneShdw>
-              </a:effectLst>
+              <a:effectLst/>
             </c:spPr>
+            <c:extLst>
+              <c:ext xmlns:c16="http://schemas.microsoft.com/office/drawing/2014/chart" uri="{C3380CC4-5D6E-409C-BE32-E72D297353CC}">
+                <c16:uniqueId val="{00000009-67D2-4D8A-AC17-6D544EE1485B}"/>
+              </c:ext>
+            </c:extLst>
           </c:dPt>
           <c:dPt>
             <c:idx val="5"/>
@@ -238,14 +234,13 @@
               <a:solidFill>
                 <a:srgbClr val="FAE0B8"/>
               </a:solidFill>
-              <a:effectLst>
-                <a:noneShdw sx="100000" sy="100000" kx="0" ky="0" algn="bl" blurRad="38100" rotWithShape="1" dist="23000" dir="5400000">
-                  <a:srgbClr val="000000">
-                    <a:alpha val="35000"/>
-                  </a:srgbClr>
-                </a:noneShdw>
-              </a:effectLst>
+              <a:effectLst/>
             </c:spPr>
+            <c:extLst>
+              <c:ext xmlns:c16="http://schemas.microsoft.com/office/drawing/2014/chart" uri="{C3380CC4-5D6E-409C-BE32-E72D297353CC}">
+                <c16:uniqueId val="{0000000B-67D2-4D8A-AC17-6D544EE1485B}"/>
+              </c:ext>
+            </c:extLst>
           </c:dPt>
           <c:dLbls>
             <c:dLbl>
@@ -264,6 +259,7 @@
                       <a:latin typeface="Arial"/>
                     </a:defRPr>
                   </a:pPr>
+                  <a:endParaRPr lang="zh-TW"/>
                 </a:p>
               </c:txPr>
               <c:showLegendKey val="0"/>
@@ -272,6 +268,12 @@
               <c:showSerName val="0"/>
               <c:showPercent val="1"/>
               <c:showBubbleSize val="0"/>
+              <c:extLst>
+                <c:ext xmlns:c15="http://schemas.microsoft.com/office/drawing/2012/chart" uri="{CE6537A1-D6FC-4f65-9D91-7224C49458BB}"/>
+                <c:ext xmlns:c16="http://schemas.microsoft.com/office/drawing/2014/chart" uri="{C3380CC4-5D6E-409C-BE32-E72D297353CC}">
+                  <c16:uniqueId val="{00000001-67D2-4D8A-AC17-6D544EE1485B}"/>
+                </c:ext>
+              </c:extLst>
             </c:dLbl>
             <c:dLbl>
               <c:idx val="1"/>
@@ -289,6 +291,7 @@
                       <a:latin typeface="Arial"/>
                     </a:defRPr>
                   </a:pPr>
+                  <a:endParaRPr lang="zh-TW"/>
                 </a:p>
               </c:txPr>
               <c:showLegendKey val="0"/>
@@ -297,6 +300,12 @@
               <c:showSerName val="0"/>
               <c:showPercent val="1"/>
               <c:showBubbleSize val="0"/>
+              <c:extLst>
+                <c:ext xmlns:c15="http://schemas.microsoft.com/office/drawing/2012/chart" uri="{CE6537A1-D6FC-4f65-9D91-7224C49458BB}"/>
+                <c:ext xmlns:c16="http://schemas.microsoft.com/office/drawing/2014/chart" uri="{C3380CC4-5D6E-409C-BE32-E72D297353CC}">
+                  <c16:uniqueId val="{00000003-67D2-4D8A-AC17-6D544EE1485B}"/>
+                </c:ext>
+              </c:extLst>
             </c:dLbl>
             <c:dLbl>
               <c:idx val="2"/>
@@ -314,6 +323,7 @@
                       <a:latin typeface="Arial"/>
                     </a:defRPr>
                   </a:pPr>
+                  <a:endParaRPr lang="zh-TW"/>
                 </a:p>
               </c:txPr>
               <c:showLegendKey val="0"/>
@@ -322,6 +332,12 @@
               <c:showSerName val="0"/>
               <c:showPercent val="1"/>
               <c:showBubbleSize val="0"/>
+              <c:extLst>
+                <c:ext xmlns:c15="http://schemas.microsoft.com/office/drawing/2012/chart" uri="{CE6537A1-D6FC-4f65-9D91-7224C49458BB}"/>
+                <c:ext xmlns:c16="http://schemas.microsoft.com/office/drawing/2014/chart" uri="{C3380CC4-5D6E-409C-BE32-E72D297353CC}">
+                  <c16:uniqueId val="{00000005-67D2-4D8A-AC17-6D544EE1485B}"/>
+                </c:ext>
+              </c:extLst>
             </c:dLbl>
             <c:dLbl>
               <c:idx val="3"/>
@@ -339,6 +355,7 @@
                       <a:latin typeface="Arial"/>
                     </a:defRPr>
                   </a:pPr>
+                  <a:endParaRPr lang="zh-TW"/>
                 </a:p>
               </c:txPr>
               <c:showLegendKey val="0"/>
@@ -347,6 +364,12 @@
               <c:showSerName val="0"/>
               <c:showPercent val="1"/>
               <c:showBubbleSize val="0"/>
+              <c:extLst>
+                <c:ext xmlns:c15="http://schemas.microsoft.com/office/drawing/2012/chart" uri="{CE6537A1-D6FC-4f65-9D91-7224C49458BB}"/>
+                <c:ext xmlns:c16="http://schemas.microsoft.com/office/drawing/2014/chart" uri="{C3380CC4-5D6E-409C-BE32-E72D297353CC}">
+                  <c16:uniqueId val="{00000007-67D2-4D8A-AC17-6D544EE1485B}"/>
+                </c:ext>
+              </c:extLst>
             </c:dLbl>
             <c:dLbl>
               <c:idx val="4"/>
@@ -364,6 +387,7 @@
                       <a:latin typeface="Arial"/>
                     </a:defRPr>
                   </a:pPr>
+                  <a:endParaRPr lang="zh-TW"/>
                 </a:p>
               </c:txPr>
               <c:showLegendKey val="0"/>
@@ -372,6 +396,12 @@
               <c:showSerName val="0"/>
               <c:showPercent val="1"/>
               <c:showBubbleSize val="0"/>
+              <c:extLst>
+                <c:ext xmlns:c15="http://schemas.microsoft.com/office/drawing/2012/chart" uri="{CE6537A1-D6FC-4f65-9D91-7224C49458BB}"/>
+                <c:ext xmlns:c16="http://schemas.microsoft.com/office/drawing/2014/chart" uri="{C3380CC4-5D6E-409C-BE32-E72D297353CC}">
+                  <c16:uniqueId val="{00000009-67D2-4D8A-AC17-6D544EE1485B}"/>
+                </c:ext>
+              </c:extLst>
             </c:dLbl>
             <c:dLbl>
               <c:idx val="5"/>
@@ -389,6 +419,7 @@
                       <a:latin typeface="Arial"/>
                     </a:defRPr>
                   </a:pPr>
+                  <a:endParaRPr lang="zh-TW"/>
                 </a:p>
               </c:txPr>
               <c:showLegendKey val="0"/>
@@ -397,8 +428,21 @@
               <c:showSerName val="0"/>
               <c:showPercent val="1"/>
               <c:showBubbleSize val="0"/>
+              <c:extLst>
+                <c:ext xmlns:c15="http://schemas.microsoft.com/office/drawing/2012/chart" uri="{CE6537A1-D6FC-4f65-9D91-7224C49458BB}"/>
+                <c:ext xmlns:c16="http://schemas.microsoft.com/office/drawing/2014/chart" uri="{C3380CC4-5D6E-409C-BE32-E72D297353CC}">
+                  <c16:uniqueId val="{0000000B-67D2-4D8A-AC17-6D544EE1485B}"/>
+                </c:ext>
+              </c:extLst>
             </c:dLbl>
             <c:numFmt formatCode="0%" sourceLinked="0"/>
+            <c:spPr>
+              <a:noFill/>
+              <a:ln>
+                <a:noFill/>
+              </a:ln>
+              <a:effectLst/>
+            </c:spPr>
             <c:txPr>
               <a:bodyPr/>
               <a:lstStyle/>
@@ -411,6 +455,7 @@
                     <a:latin typeface="Arial"/>
                   </a:defRPr>
                 </a:pPr>
+                <a:endParaRPr lang="zh-TW"/>
               </a:p>
             </c:txPr>
             <c:dLblPos val="ctr"/>
@@ -421,6 +466,9 @@
             <c:showPercent val="1"/>
             <c:showBubbleSize val="0"/>
             <c:showLeaderLines val="0"/>
+            <c:extLst>
+              <c:ext xmlns:c15="http://schemas.microsoft.com/office/drawing/2012/chart" uri="{CE6537A1-D6FC-4f65-9D91-7224C49458BB}"/>
+            </c:extLst>
           </c:dLbls>
           <c:cat>
             <c:strRef>
@@ -452,6 +500,7 @@
             <c:numRef>
               <c:f>Sheet1!$B$2:$B$7</c:f>
               <c:numCache>
+                <c:formatCode>General</c:formatCode>
                 <c:ptCount val="6"/>
                 <c:pt idx="0">
                   <c:v>11</c:v>
@@ -474,7 +523,21 @@
               </c:numCache>
             </c:numRef>
           </c:val>
+          <c:extLst>
+            <c:ext xmlns:c16="http://schemas.microsoft.com/office/drawing/2014/chart" uri="{C3380CC4-5D6E-409C-BE32-E72D297353CC}">
+              <c16:uniqueId val="{0000000C-67D2-4D8A-AC17-6D544EE1485B}"/>
+            </c:ext>
+          </c:extLst>
         </c:ser>
+        <c:dLbls>
+          <c:showLegendKey val="0"/>
+          <c:showVal val="0"/>
+          <c:showCatName val="0"/>
+          <c:showSerName val="0"/>
+          <c:showPercent val="0"/>
+          <c:showBubbleSize val="0"/>
+          <c:showLeaderLines val="0"/>
+        </c:dLbls>
         <c:firstSliceAng val="0"/>
       </c:pieChart>
       <c:spPr>
@@ -487,6 +550,7 @@
     </c:plotArea>
     <c:plotVisOnly val="1"/>
     <c:dispBlanksAs val="span"/>
+    <c:showDLblsOverMax val="1"/>
   </c:chart>
   <c:spPr>
     <a:noFill/>
@@ -502,9 +566,11 @@
 </file>
 
 <file path=ppt/charts/chart2.xml><?xml version="1.0" encoding="utf-8"?>
-<c:chartSpace xmlns:c="http://schemas.openxmlformats.org/drawingml/2006/chart" xmlns:a="http://schemas.openxmlformats.org/drawingml/2006/main" xmlns:r="http://schemas.openxmlformats.org/officeDocument/2006/relationships">
+<c:chartSpace xmlns:c="http://schemas.openxmlformats.org/drawingml/2006/chart" xmlns:a="http://schemas.openxmlformats.org/drawingml/2006/main" xmlns:r="http://schemas.openxmlformats.org/officeDocument/2006/relationships" xmlns:c16r2="http://schemas.microsoft.com/office/drawing/2015/06/chart">
   <c:date1904 val="0"/>
+  <c:lang val="zh-TW"/>
   <c:roundedCorners val="1"/>
+  <c:style val="2"/>
   <c:chart>
     <c:autoTitleDeleted val="1"/>
     <c:plotArea>
@@ -536,13 +602,7 @@
               <a:prstDash val="solid"/>
               <a:round/>
             </a:ln>
-            <a:effectLst>
-              <a:noneShdw sx="100000" sy="100000" kx="0" ky="0" algn="bl" blurRad="38100" rotWithShape="1" dist="23000" dir="5400000">
-                <a:srgbClr val="000000">
-                  <a:alpha val="35000"/>
-                </a:srgbClr>
-              </a:noneShdw>
-            </a:effectLst>
+            <a:effectLst/>
           </c:spPr>
           <c:dPt>
             <c:idx val="0"/>
@@ -551,14 +611,13 @@
               <a:solidFill>
                 <a:srgbClr val="FF5000"/>
               </a:solidFill>
-              <a:effectLst>
-                <a:noneShdw sx="100000" sy="100000" kx="0" ky="0" algn="bl" blurRad="38100" rotWithShape="1" dist="23000" dir="5400000">
-                  <a:srgbClr val="000000">
-                    <a:alpha val="35000"/>
-                  </a:srgbClr>
-                </a:noneShdw>
-              </a:effectLst>
+              <a:effectLst/>
             </c:spPr>
+            <c:extLst>
+              <c:ext xmlns:c16="http://schemas.microsoft.com/office/drawing/2014/chart" uri="{C3380CC4-5D6E-409C-BE32-E72D297353CC}">
+                <c16:uniqueId val="{00000001-6ADF-4843-9DAE-157EC923871C}"/>
+              </c:ext>
+            </c:extLst>
           </c:dPt>
           <c:dPt>
             <c:idx val="1"/>
@@ -567,14 +626,13 @@
               <a:solidFill>
                 <a:srgbClr val="060E9F"/>
               </a:solidFill>
-              <a:effectLst>
-                <a:noneShdw sx="100000" sy="100000" kx="0" ky="0" algn="bl" blurRad="38100" rotWithShape="1" dist="23000" dir="5400000">
-                  <a:srgbClr val="000000">
-                    <a:alpha val="35000"/>
-                  </a:srgbClr>
-                </a:noneShdw>
-              </a:effectLst>
+              <a:effectLst/>
             </c:spPr>
+            <c:extLst>
+              <c:ext xmlns:c16="http://schemas.microsoft.com/office/drawing/2014/chart" uri="{C3380CC4-5D6E-409C-BE32-E72D297353CC}">
+                <c16:uniqueId val="{00000003-6ADF-4843-9DAE-157EC923871C}"/>
+              </c:ext>
+            </c:extLst>
           </c:dPt>
           <c:dPt>
             <c:idx val="2"/>
@@ -583,14 +641,13 @@
               <a:solidFill>
                 <a:srgbClr val="0076A9"/>
               </a:solidFill>
-              <a:effectLst>
-                <a:noneShdw sx="100000" sy="100000" kx="0" ky="0" algn="bl" blurRad="38100" rotWithShape="1" dist="23000" dir="5400000">
-                  <a:srgbClr val="000000">
-                    <a:alpha val="35000"/>
-                  </a:srgbClr>
-                </a:noneShdw>
-              </a:effectLst>
+              <a:effectLst/>
             </c:spPr>
+            <c:extLst>
+              <c:ext xmlns:c16="http://schemas.microsoft.com/office/drawing/2014/chart" uri="{C3380CC4-5D6E-409C-BE32-E72D297353CC}">
+                <c16:uniqueId val="{00000005-6ADF-4843-9DAE-157EC923871C}"/>
+              </c:ext>
+            </c:extLst>
           </c:dPt>
           <c:dPt>
             <c:idx val="3"/>
@@ -599,14 +656,13 @@
               <a:solidFill>
                 <a:srgbClr val="FFCE00"/>
               </a:solidFill>
-              <a:effectLst>
-                <a:noneShdw sx="100000" sy="100000" kx="0" ky="0" algn="bl" blurRad="38100" rotWithShape="1" dist="23000" dir="5400000">
-                  <a:srgbClr val="000000">
-                    <a:alpha val="35000"/>
-                  </a:srgbClr>
-                </a:noneShdw>
-              </a:effectLst>
+              <a:effectLst/>
             </c:spPr>
+            <c:extLst>
+              <c:ext xmlns:c16="http://schemas.microsoft.com/office/drawing/2014/chart" uri="{C3380CC4-5D6E-409C-BE32-E72D297353CC}">
+                <c16:uniqueId val="{00000007-6ADF-4843-9DAE-157EC923871C}"/>
+              </c:ext>
+            </c:extLst>
           </c:dPt>
           <c:dPt>
             <c:idx val="4"/>
@@ -615,14 +671,13 @@
               <a:solidFill>
                 <a:srgbClr val="8EB8C9"/>
               </a:solidFill>
-              <a:effectLst>
-                <a:noneShdw sx="100000" sy="100000" kx="0" ky="0" algn="bl" blurRad="38100" rotWithShape="1" dist="23000" dir="5400000">
-                  <a:srgbClr val="000000">
-                    <a:alpha val="35000"/>
-                  </a:srgbClr>
-                </a:noneShdw>
-              </a:effectLst>
+              <a:effectLst/>
             </c:spPr>
+            <c:extLst>
+              <c:ext xmlns:c16="http://schemas.microsoft.com/office/drawing/2014/chart" uri="{C3380CC4-5D6E-409C-BE32-E72D297353CC}">
+                <c16:uniqueId val="{00000009-6ADF-4843-9DAE-157EC923871C}"/>
+              </c:ext>
+            </c:extLst>
           </c:dPt>
           <c:dPt>
             <c:idx val="5"/>
@@ -631,14 +686,13 @@
               <a:solidFill>
                 <a:srgbClr val="B8BEC8"/>
               </a:solidFill>
-              <a:effectLst>
-                <a:noneShdw sx="100000" sy="100000" kx="0" ky="0" algn="bl" blurRad="38100" rotWithShape="1" dist="23000" dir="5400000">
-                  <a:srgbClr val="000000">
-                    <a:alpha val="35000"/>
-                  </a:srgbClr>
-                </a:noneShdw>
-              </a:effectLst>
+              <a:effectLst/>
             </c:spPr>
+            <c:extLst>
+              <c:ext xmlns:c16="http://schemas.microsoft.com/office/drawing/2014/chart" uri="{C3380CC4-5D6E-409C-BE32-E72D297353CC}">
+                <c16:uniqueId val="{0000000B-6ADF-4843-9DAE-157EC923871C}"/>
+              </c:ext>
+            </c:extLst>
           </c:dPt>
           <c:dLbls>
             <c:dLbl>
@@ -657,6 +711,7 @@
                       <a:latin typeface="Arial"/>
                     </a:defRPr>
                   </a:pPr>
+                  <a:endParaRPr lang="zh-TW"/>
                 </a:p>
               </c:txPr>
               <c:showLegendKey val="0"/>
@@ -665,6 +720,12 @@
               <c:showSerName val="0"/>
               <c:showPercent val="1"/>
               <c:showBubbleSize val="0"/>
+              <c:extLst>
+                <c:ext xmlns:c15="http://schemas.microsoft.com/office/drawing/2012/chart" uri="{CE6537A1-D6FC-4f65-9D91-7224C49458BB}"/>
+                <c:ext xmlns:c16="http://schemas.microsoft.com/office/drawing/2014/chart" uri="{C3380CC4-5D6E-409C-BE32-E72D297353CC}">
+                  <c16:uniqueId val="{00000001-6ADF-4843-9DAE-157EC923871C}"/>
+                </c:ext>
+              </c:extLst>
             </c:dLbl>
             <c:dLbl>
               <c:idx val="1"/>
@@ -682,6 +743,7 @@
                       <a:latin typeface="Arial"/>
                     </a:defRPr>
                   </a:pPr>
+                  <a:endParaRPr lang="zh-TW"/>
                 </a:p>
               </c:txPr>
               <c:showLegendKey val="0"/>
@@ -690,6 +752,12 @@
               <c:showSerName val="0"/>
               <c:showPercent val="1"/>
               <c:showBubbleSize val="0"/>
+              <c:extLst>
+                <c:ext xmlns:c15="http://schemas.microsoft.com/office/drawing/2012/chart" uri="{CE6537A1-D6FC-4f65-9D91-7224C49458BB}"/>
+                <c:ext xmlns:c16="http://schemas.microsoft.com/office/drawing/2014/chart" uri="{C3380CC4-5D6E-409C-BE32-E72D297353CC}">
+                  <c16:uniqueId val="{00000003-6ADF-4843-9DAE-157EC923871C}"/>
+                </c:ext>
+              </c:extLst>
             </c:dLbl>
             <c:dLbl>
               <c:idx val="2"/>
@@ -707,6 +775,7 @@
                       <a:latin typeface="Arial"/>
                     </a:defRPr>
                   </a:pPr>
+                  <a:endParaRPr lang="zh-TW"/>
                 </a:p>
               </c:txPr>
               <c:showLegendKey val="0"/>
@@ -715,6 +784,12 @@
               <c:showSerName val="0"/>
               <c:showPercent val="1"/>
               <c:showBubbleSize val="0"/>
+              <c:extLst>
+                <c:ext xmlns:c15="http://schemas.microsoft.com/office/drawing/2012/chart" uri="{CE6537A1-D6FC-4f65-9D91-7224C49458BB}"/>
+                <c:ext xmlns:c16="http://schemas.microsoft.com/office/drawing/2014/chart" uri="{C3380CC4-5D6E-409C-BE32-E72D297353CC}">
+                  <c16:uniqueId val="{00000005-6ADF-4843-9DAE-157EC923871C}"/>
+                </c:ext>
+              </c:extLst>
             </c:dLbl>
             <c:dLbl>
               <c:idx val="3"/>
@@ -732,6 +807,7 @@
                       <a:latin typeface="Arial"/>
                     </a:defRPr>
                   </a:pPr>
+                  <a:endParaRPr lang="zh-TW"/>
                 </a:p>
               </c:txPr>
               <c:showLegendKey val="0"/>
@@ -740,6 +816,12 @@
               <c:showSerName val="0"/>
               <c:showPercent val="1"/>
               <c:showBubbleSize val="0"/>
+              <c:extLst>
+                <c:ext xmlns:c15="http://schemas.microsoft.com/office/drawing/2012/chart" uri="{CE6537A1-D6FC-4f65-9D91-7224C49458BB}"/>
+                <c:ext xmlns:c16="http://schemas.microsoft.com/office/drawing/2014/chart" uri="{C3380CC4-5D6E-409C-BE32-E72D297353CC}">
+                  <c16:uniqueId val="{00000007-6ADF-4843-9DAE-157EC923871C}"/>
+                </c:ext>
+              </c:extLst>
             </c:dLbl>
             <c:dLbl>
               <c:idx val="4"/>
@@ -757,6 +839,7 @@
                       <a:latin typeface="Arial"/>
                     </a:defRPr>
                   </a:pPr>
+                  <a:endParaRPr lang="zh-TW"/>
                 </a:p>
               </c:txPr>
               <c:showLegendKey val="0"/>
@@ -765,6 +848,12 @@
               <c:showSerName val="0"/>
               <c:showPercent val="1"/>
               <c:showBubbleSize val="0"/>
+              <c:extLst>
+                <c:ext xmlns:c15="http://schemas.microsoft.com/office/drawing/2012/chart" uri="{CE6537A1-D6FC-4f65-9D91-7224C49458BB}"/>
+                <c:ext xmlns:c16="http://schemas.microsoft.com/office/drawing/2014/chart" uri="{C3380CC4-5D6E-409C-BE32-E72D297353CC}">
+                  <c16:uniqueId val="{00000009-6ADF-4843-9DAE-157EC923871C}"/>
+                </c:ext>
+              </c:extLst>
             </c:dLbl>
             <c:dLbl>
               <c:idx val="5"/>
@@ -782,6 +871,7 @@
                       <a:latin typeface="Arial"/>
                     </a:defRPr>
                   </a:pPr>
+                  <a:endParaRPr lang="zh-TW"/>
                 </a:p>
               </c:txPr>
               <c:showLegendKey val="0"/>
@@ -790,8 +880,21 @@
               <c:showSerName val="0"/>
               <c:showPercent val="1"/>
               <c:showBubbleSize val="0"/>
+              <c:extLst>
+                <c:ext xmlns:c15="http://schemas.microsoft.com/office/drawing/2012/chart" uri="{CE6537A1-D6FC-4f65-9D91-7224C49458BB}"/>
+                <c:ext xmlns:c16="http://schemas.microsoft.com/office/drawing/2014/chart" uri="{C3380CC4-5D6E-409C-BE32-E72D297353CC}">
+                  <c16:uniqueId val="{0000000B-6ADF-4843-9DAE-157EC923871C}"/>
+                </c:ext>
+              </c:extLst>
             </c:dLbl>
             <c:numFmt formatCode="0%" sourceLinked="0"/>
+            <c:spPr>
+              <a:noFill/>
+              <a:ln>
+                <a:noFill/>
+              </a:ln>
+              <a:effectLst/>
+            </c:spPr>
             <c:txPr>
               <a:bodyPr/>
               <a:lstStyle/>
@@ -804,6 +907,7 @@
                     <a:latin typeface="Arial"/>
                   </a:defRPr>
                 </a:pPr>
+                <a:endParaRPr lang="zh-TW"/>
               </a:p>
             </c:txPr>
             <c:dLblPos val="ctr"/>
@@ -814,6 +918,9 @@
             <c:showPercent val="1"/>
             <c:showBubbleSize val="0"/>
             <c:showLeaderLines val="0"/>
+            <c:extLst>
+              <c:ext xmlns:c15="http://schemas.microsoft.com/office/drawing/2012/chart" uri="{CE6537A1-D6FC-4f65-9D91-7224C49458BB}"/>
+            </c:extLst>
           </c:dLbls>
           <c:cat>
             <c:strRef>
@@ -845,6 +952,7 @@
             <c:numRef>
               <c:f>Sheet1!$B$2:$B$7</c:f>
               <c:numCache>
+                <c:formatCode>General</c:formatCode>
                 <c:ptCount val="6"/>
                 <c:pt idx="0">
                   <c:v>13</c:v>
@@ -867,7 +975,21 @@
               </c:numCache>
             </c:numRef>
           </c:val>
+          <c:extLst>
+            <c:ext xmlns:c16="http://schemas.microsoft.com/office/drawing/2014/chart" uri="{C3380CC4-5D6E-409C-BE32-E72D297353CC}">
+              <c16:uniqueId val="{0000000C-6ADF-4843-9DAE-157EC923871C}"/>
+            </c:ext>
+          </c:extLst>
         </c:ser>
+        <c:dLbls>
+          <c:showLegendKey val="0"/>
+          <c:showVal val="0"/>
+          <c:showCatName val="0"/>
+          <c:showSerName val="0"/>
+          <c:showPercent val="0"/>
+          <c:showBubbleSize val="0"/>
+          <c:showLeaderLines val="0"/>
+        </c:dLbls>
         <c:firstSliceAng val="0"/>
       </c:pieChart>
       <c:spPr>
@@ -880,6 +1002,7 @@
     </c:plotArea>
     <c:plotVisOnly val="1"/>
     <c:dispBlanksAs val="span"/>
+    <c:showDLblsOverMax val="1"/>
   </c:chart>
   <c:spPr>
     <a:noFill/>
@@ -916,234 +1039,10 @@
           <a:chExt cx="0" cy="0"/>
         </a:xfrm>
       </p:grpSpPr>
-      <p:sp>
-        <p:nvSpPr>
-          <p:cNvPr id="2" name="Header Placeholder 1"/>
-          <p:cNvSpPr>
-            <a:spLocks noGrp="1"/>
-          </p:cNvSpPr>
-          <p:nvPr>
-            <p:ph type="hdr" sz="quarter"/>
-          </p:nvPr>
-        </p:nvSpPr>
-        <p:spPr>
-          <a:xfrm>
-            <a:off x="0" y="0"/>
-            <a:ext cx="2971800" cy="458788"/>
-          </a:xfrm>
-          <a:prstGeom prst="rect">
-            <a:avLst/>
-          </a:prstGeom>
-        </p:spPr>
-        <p:txBody>
-          <a:bodyPr vert="horz" lIns="91440" tIns="45720" rIns="91440" bIns="45720" rtlCol="0"/>
-          <a:lstStyle>
-            <a:lvl1pPr algn="l">
-              <a:defRPr sz="1200"/>
-            </a:lvl1pPr>
-          </a:lstStyle>
-          <a:p>
-            <a:endParaRPr lang="en-US"/>
-          </a:p>
-        </p:txBody>
-      </p:sp>
-      <p:sp>
-        <p:nvSpPr>
-          <p:cNvPr id="3" name="Date Placeholder 2"/>
-          <p:cNvSpPr>
-            <a:spLocks noGrp="1"/>
-          </p:cNvSpPr>
-          <p:nvPr>
-            <p:ph type="dt" idx="1"/>
-          </p:nvPr>
-        </p:nvSpPr>
-        <p:spPr>
-          <a:xfrm>
-            <a:off x="3884613" y="0"/>
-            <a:ext cx="2971800" cy="458788"/>
-          </a:xfrm>
-          <a:prstGeom prst="rect">
-            <a:avLst/>
-          </a:prstGeom>
-        </p:spPr>
-        <p:txBody>
-          <a:bodyPr vert="horz" lIns="91440" tIns="45720" rIns="91440" bIns="45720" rtlCol="0"/>
-          <a:lstStyle>
-            <a:lvl1pPr algn="r">
-              <a:defRPr sz="1200"/>
-            </a:lvl1pPr>
-          </a:lstStyle>
-          <a:p>
-            <a:fld id="{5282F153-3F37-0F45-9E97-73ACFA13230C}" type="datetimeFigureOut">
-              <a:rPr lang="en-US"/>
-              <a:t>7/23/19</a:t>
-            </a:fld>
-            <a:endParaRPr lang="en-US"/>
-          </a:p>
-        </p:txBody>
-      </p:sp>
-      <p:sp>
-        <p:nvSpPr>
-          <p:cNvPr id="4" name="Slide Image Placeholder 3"/>
-          <p:cNvSpPr>
-            <a:spLocks noGrp="1" noRot="1" noChangeAspect="1"/>
-          </p:cNvSpPr>
-          <p:nvPr>
-            <p:ph type="sldImg" idx="2"/>
-          </p:nvPr>
-        </p:nvSpPr>
-        <p:spPr>
-          <a:xfrm>
-            <a:off x="685800" y="1143000"/>
-            <a:ext cx="5486400" cy="3086100"/>
-          </a:xfrm>
-          <a:prstGeom prst="rect">
-            <a:avLst/>
-          </a:prstGeom>
-          <a:noFill/>
-          <a:ln w="12700">
-            <a:solidFill>
-              <a:prstClr val="black"/>
-            </a:solidFill>
-          </a:ln>
-        </p:spPr>
-        <p:txBody>
-          <a:bodyPr vert="horz" lIns="91440" tIns="45720" rIns="91440" bIns="45720" rtlCol="0" anchor="ctr"/>
-          <a:lstStyle/>
-          <a:p>
-            <a:endParaRPr lang="en-US"/>
-          </a:p>
-        </p:txBody>
-      </p:sp>
-      <p:sp>
-        <p:nvSpPr>
-          <p:cNvPr id="5" name="Notes Placeholder 4"/>
-          <p:cNvSpPr>
-            <a:spLocks noGrp="1"/>
-          </p:cNvSpPr>
-          <p:nvPr>
-            <p:ph type="body" sz="quarter" idx="3"/>
-          </p:nvPr>
-        </p:nvSpPr>
-        <p:spPr>
-          <a:xfrm>
-            <a:off x="685800" y="4400550"/>
-            <a:ext cx="5486400" cy="3600450"/>
-          </a:xfrm>
-          <a:prstGeom prst="rect">
-            <a:avLst/>
-          </a:prstGeom>
-        </p:spPr>
-        <p:txBody>
-          <a:bodyPr vert="horz" lIns="91440" tIns="45720" rIns="91440" bIns="45720" rtlCol="0"/>
-          <a:lstStyle/>
-          <a:p>
-            <a:pPr lvl="0"/>
-            <a:r>
-              <a:rPr lang="en-US"/>
-              <a:t>Click to edit Master text styles</a:t>
-            </a:r>
-          </a:p>
-          <a:p>
-            <a:pPr lvl="1"/>
-            <a:r>
-              <a:rPr lang="en-US"/>
-              <a:t>Second level</a:t>
-            </a:r>
-          </a:p>
-          <a:p>
-            <a:pPr lvl="2"/>
-            <a:r>
-              <a:rPr lang="en-US"/>
-              <a:t>Third level</a:t>
-            </a:r>
-          </a:p>
-          <a:p>
-            <a:pPr lvl="3"/>
-            <a:r>
-              <a:rPr lang="en-US"/>
-              <a:t>Fourth level</a:t>
-            </a:r>
-          </a:p>
-          <a:p>
-            <a:pPr lvl="4"/>
-            <a:r>
-              <a:rPr lang="en-US"/>
-              <a:t>Fifth level</a:t>
-            </a:r>
-          </a:p>
-        </p:txBody>
-      </p:sp>
-      <p:sp>
-        <p:nvSpPr>
-          <p:cNvPr id="6" name="Footer Placeholder 5"/>
-          <p:cNvSpPr>
-            <a:spLocks noGrp="1"/>
-          </p:cNvSpPr>
-          <p:nvPr>
-            <p:ph type="ftr" sz="quarter" idx="4"/>
-          </p:nvPr>
-        </p:nvSpPr>
-        <p:spPr>
-          <a:xfrm>
-            <a:off x="0" y="8685213"/>
-            <a:ext cx="2971800" cy="458787"/>
-          </a:xfrm>
-          <a:prstGeom prst="rect">
-            <a:avLst/>
-          </a:prstGeom>
-        </p:spPr>
-        <p:txBody>
-          <a:bodyPr vert="horz" lIns="91440" tIns="45720" rIns="91440" bIns="45720" rtlCol="0" anchor="b"/>
-          <a:lstStyle>
-            <a:lvl1pPr algn="l">
-              <a:defRPr sz="1200"/>
-            </a:lvl1pPr>
-          </a:lstStyle>
-          <a:p>
-            <a:endParaRPr lang="en-US"/>
-          </a:p>
-        </p:txBody>
-      </p:sp>
-      <p:sp>
-        <p:nvSpPr>
-          <p:cNvPr id="7" name="Slide Number Placeholder 6"/>
-          <p:cNvSpPr>
-            <a:spLocks noGrp="1"/>
-          </p:cNvSpPr>
-          <p:nvPr>
-            <p:ph type="sldNum" sz="quarter" idx="5"/>
-          </p:nvPr>
-        </p:nvSpPr>
-        <p:spPr>
-          <a:xfrm>
-            <a:off x="3884613" y="8685213"/>
-            <a:ext cx="2971800" cy="458787"/>
-          </a:xfrm>
-          <a:prstGeom prst="rect">
-            <a:avLst/>
-          </a:prstGeom>
-        </p:spPr>
-        <p:txBody>
-          <a:bodyPr vert="horz" lIns="91440" tIns="45720" rIns="91440" bIns="45720" rtlCol="0" anchor="b"/>
-          <a:lstStyle>
-            <a:lvl1pPr algn="r">
-              <a:defRPr sz="1200"/>
-            </a:lvl1pPr>
-          </a:lstStyle>
-          <a:p>
-            <a:fld id="{CE5E9CC1-C706-0F49-92D6-E571CC5EEA8F}" type="slidenum">
-              <a:rPr lang="en-US"/>
-              <a:t>‹#›</a:t>
-            </a:fld>
-            <a:endParaRPr lang="en-US"/>
-          </a:p>
-        </p:txBody>
-      </p:sp>
     </p:spTree>
     <p:extLst>
       <p:ext uri="{BB962C8B-B14F-4D97-AF65-F5344CB8AC3E}">
-        <p14:creationId xmlns:p14="http://schemas.microsoft.com/office/powerpoint/2010/main" val="1024086991"/>
+        <p14:creationId xmlns:p14="http://schemas.microsoft.com/office/powerpoint/2010/main" val="4028413504"/>
       </p:ext>
     </p:extLst>
   </p:cSld>
@@ -1287,10 +1186,6 @@
           <a:bodyPr/>
           <a:lstStyle/>
           <a:p>
-            <a:r>
-              <a:rPr lang="en-US" dirty="0"/>
-              <a:t/>
-            </a:r>
             <a:endParaRPr lang="en-US" dirty="0"/>
           </a:p>
         </p:txBody>
@@ -1375,10 +1270,6 @@
           <a:bodyPr/>
           <a:lstStyle/>
           <a:p>
-            <a:r>
-              <a:rPr lang="en-US" dirty="0"/>
-              <a:t/>
-            </a:r>
             <a:endParaRPr lang="en-US" dirty="0"/>
           </a:p>
         </p:txBody>
@@ -1452,6 +1343,11 @@
 <file path=ppt/slideMasters/slideMaster1.xml><?xml version="1.0" encoding="utf-8"?>
 <p:sldMaster xmlns:a="http://schemas.openxmlformats.org/drawingml/2006/main" xmlns:r="http://schemas.openxmlformats.org/officeDocument/2006/relationships" xmlns:p="http://schemas.openxmlformats.org/presentationml/2006/main">
   <p:cSld>
+    <p:bg>
+      <p:bgRef idx="1001">
+        <a:schemeClr val="bg1"/>
+      </p:bgRef>
+    </p:bg>
     <p:spTree>
       <p:nvGrpSpPr>
         <p:cNvPr id="1" name=""/>
@@ -1734,6 +1630,7 @@
         <a:solidFill>
           <a:srgbClr val="FFFFFF"/>
         </a:solidFill>
+        <a:effectLst/>
       </p:bgPr>
     </p:bg>
     <p:spTree>
@@ -1771,7 +1668,7 @@
           <a:bodyPr wrap="square" rtlCol="0" anchor="ctr"/>
           <a:lstStyle/>
           <a:p>
-            <a:pPr indent="0" marL="0">
+            <a:pPr marL="0" indent="0">
               <a:buNone/>
             </a:pPr>
             <a:r>
@@ -1808,6 +1705,13 @@
           </a:solidFill>
           <a:ln/>
         </p:spPr>
+        <p:txBody>
+          <a:bodyPr/>
+          <a:lstStyle/>
+          <a:p>
+            <a:endParaRPr lang="zh-TW" altLang="en-US"/>
+          </a:p>
+        </p:txBody>
       </p:sp>
       <p:sp>
         <p:nvSpPr>
@@ -1830,7 +1734,7 @@
           <a:bodyPr wrap="square" rtlCol="0" anchor="ctr"/>
           <a:lstStyle/>
           <a:p>
-            <a:pPr indent="0" marL="0">
+            <a:pPr marL="0" indent="0">
               <a:buNone/>
             </a:pPr>
             <a:r>
@@ -1850,7 +1754,7 @@
       </p:sp>
       <p:graphicFrame>
         <p:nvGraphicFramePr>
-          <p:cNvPr id="2" name="Table 0"/>
+          <p:cNvPr id="5" name="Table 0"/>
           <p:cNvGraphicFramePr>
             <a:graphicFrameLocks noGrp="1"/>
           </p:cNvGraphicFramePr>
@@ -1864,22 +1768,76 @@
         </p:nvGraphicFramePr>
         <p:xfrm>
           <a:off x="164592" y="548640"/>
-          <a:ext cx="8814816" cy="1792224"/>
+          <a:ext cx="8211312" cy="1691640"/>
         </p:xfrm>
         <a:graphic>
           <a:graphicData uri="http://schemas.openxmlformats.org/drawingml/2006/table">
             <a:tbl>
               <a:tblPr/>
               <a:tblGrid>
-                <a:gridCol w="960120"/>
-                <a:gridCol w="1051560"/>
-                <a:gridCol w="1005840"/>
-                <a:gridCol w="1005840"/>
-                <a:gridCol w="1005840"/>
-                <a:gridCol w="804672"/>
-                <a:gridCol w="804672"/>
-                <a:gridCol w="804672"/>
-                <a:gridCol w="768096"/>
+                <a:gridCol w="960120">
+                  <a:extLst>
+                    <a:ext uri="{9D8B030D-6E8A-4147-A177-3AD203B41FA5}">
+                      <a16:colId xmlns:a16="http://schemas.microsoft.com/office/drawing/2014/main" val="20000"/>
+                    </a:ext>
+                  </a:extLst>
+                </a:gridCol>
+                <a:gridCol w="1051560">
+                  <a:extLst>
+                    <a:ext uri="{9D8B030D-6E8A-4147-A177-3AD203B41FA5}">
+                      <a16:colId xmlns:a16="http://schemas.microsoft.com/office/drawing/2014/main" val="20001"/>
+                    </a:ext>
+                  </a:extLst>
+                </a:gridCol>
+                <a:gridCol w="1005840">
+                  <a:extLst>
+                    <a:ext uri="{9D8B030D-6E8A-4147-A177-3AD203B41FA5}">
+                      <a16:colId xmlns:a16="http://schemas.microsoft.com/office/drawing/2014/main" val="20002"/>
+                    </a:ext>
+                  </a:extLst>
+                </a:gridCol>
+                <a:gridCol w="1005840">
+                  <a:extLst>
+                    <a:ext uri="{9D8B030D-6E8A-4147-A177-3AD203B41FA5}">
+                      <a16:colId xmlns:a16="http://schemas.microsoft.com/office/drawing/2014/main" val="20003"/>
+                    </a:ext>
+                  </a:extLst>
+                </a:gridCol>
+                <a:gridCol w="1005840">
+                  <a:extLst>
+                    <a:ext uri="{9D8B030D-6E8A-4147-A177-3AD203B41FA5}">
+                      <a16:colId xmlns:a16="http://schemas.microsoft.com/office/drawing/2014/main" val="20004"/>
+                    </a:ext>
+                  </a:extLst>
+                </a:gridCol>
+                <a:gridCol w="804672">
+                  <a:extLst>
+                    <a:ext uri="{9D8B030D-6E8A-4147-A177-3AD203B41FA5}">
+                      <a16:colId xmlns:a16="http://schemas.microsoft.com/office/drawing/2014/main" val="20005"/>
+                    </a:ext>
+                  </a:extLst>
+                </a:gridCol>
+                <a:gridCol w="804672">
+                  <a:extLst>
+                    <a:ext uri="{9D8B030D-6E8A-4147-A177-3AD203B41FA5}">
+                      <a16:colId xmlns:a16="http://schemas.microsoft.com/office/drawing/2014/main" val="20006"/>
+                    </a:ext>
+                  </a:extLst>
+                </a:gridCol>
+                <a:gridCol w="804672">
+                  <a:extLst>
+                    <a:ext uri="{9D8B030D-6E8A-4147-A177-3AD203B41FA5}">
+                      <a16:colId xmlns:a16="http://schemas.microsoft.com/office/drawing/2014/main" val="20007"/>
+                    </a:ext>
+                  </a:extLst>
+                </a:gridCol>
+                <a:gridCol w="768096">
+                  <a:extLst>
+                    <a:ext uri="{9D8B030D-6E8A-4147-A177-3AD203B41FA5}">
+                      <a16:colId xmlns:a16="http://schemas.microsoft.com/office/drawing/2014/main" val="20008"/>
+                    </a:ext>
+                  </a:extLst>
+                </a:gridCol>
               </a:tblGrid>
               <a:tr h="338328">
                 <a:tc>
@@ -1887,7 +1845,7 @@
                     <a:bodyPr/>
                     <a:lstStyle/>
                     <a:p>
-                      <a:pPr algn="ctr" indent="0" marL="0">
+                      <a:pPr marL="0" indent="0" algn="ctr">
                         <a:buNone/>
                       </a:pPr>
                       <a:r>
@@ -1908,7 +1866,7 @@
                       </a:endParaRPr>
                     </a:p>
                   </a:txBody>
-                  <a:tcPr marL="91440" marR="91440" marT="45720" marB="45720">
+                  <a:tcPr>
                     <a:lnL w="6350" cap="flat" cmpd="sng" algn="ctr">
                       <a:solidFill>
                         <a:srgbClr val="D1DCF0"/>
@@ -1955,7 +1913,7 @@
                     <a:bodyPr/>
                     <a:lstStyle/>
                     <a:p>
-                      <a:pPr algn="ctr" indent="0" marL="0">
+                      <a:pPr marL="0" indent="0" algn="ctr">
                         <a:buNone/>
                       </a:pPr>
                       <a:r>
@@ -1976,7 +1934,7 @@
                       </a:endParaRPr>
                     </a:p>
                   </a:txBody>
-                  <a:tcPr marL="91440" marR="91440" marT="45720" marB="45720">
+                  <a:tcPr>
                     <a:lnL w="6350" cap="flat" cmpd="sng" algn="ctr">
                       <a:solidFill>
                         <a:srgbClr val="D1DCF0"/>
@@ -2023,7 +1981,7 @@
                     <a:bodyPr/>
                     <a:lstStyle/>
                     <a:p>
-                      <a:pPr algn="ctr" indent="0" marL="0">
+                      <a:pPr marL="0" indent="0" algn="ctr">
                         <a:buNone/>
                       </a:pPr>
                       <a:r>
@@ -2044,7 +2002,7 @@
                       </a:endParaRPr>
                     </a:p>
                   </a:txBody>
-                  <a:tcPr marL="91440" marR="91440" marT="45720" marB="45720">
+                  <a:tcPr>
                     <a:lnL w="6350" cap="flat" cmpd="sng" algn="ctr">
                       <a:solidFill>
                         <a:srgbClr val="D1DCF0"/>
@@ -2091,7 +2049,7 @@
                     <a:bodyPr/>
                     <a:lstStyle/>
                     <a:p>
-                      <a:pPr algn="ctr" indent="0" marL="0">
+                      <a:pPr marL="0" indent="0" algn="ctr">
                         <a:buNone/>
                       </a:pPr>
                       <a:r>
@@ -2112,7 +2070,7 @@
                       </a:endParaRPr>
                     </a:p>
                   </a:txBody>
-                  <a:tcPr marL="91440" marR="91440" marT="45720" marB="45720">
+                  <a:tcPr>
                     <a:lnL w="6350" cap="flat" cmpd="sng" algn="ctr">
                       <a:solidFill>
                         <a:srgbClr val="D1DCF0"/>
@@ -2159,7 +2117,7 @@
                     <a:bodyPr/>
                     <a:lstStyle/>
                     <a:p>
-                      <a:pPr algn="ctr" indent="0" marL="0">
+                      <a:pPr marL="0" indent="0" algn="ctr">
                         <a:buNone/>
                       </a:pPr>
                       <a:r>
@@ -2180,7 +2138,7 @@
                       </a:endParaRPr>
                     </a:p>
                   </a:txBody>
-                  <a:tcPr marL="91440" marR="91440" marT="45720" marB="45720">
+                  <a:tcPr>
                     <a:lnL w="6350" cap="flat" cmpd="sng" algn="ctr">
                       <a:solidFill>
                         <a:srgbClr val="D1DCF0"/>
@@ -2227,7 +2185,7 @@
                     <a:bodyPr/>
                     <a:lstStyle/>
                     <a:p>
-                      <a:pPr algn="ctr" indent="0" marL="0">
+                      <a:pPr marL="0" indent="0" algn="ctr">
                         <a:buNone/>
                       </a:pPr>
                       <a:r>
@@ -2248,7 +2206,7 @@
                       </a:endParaRPr>
                     </a:p>
                   </a:txBody>
-                  <a:tcPr marL="91440" marR="91440" marT="45720" marB="45720">
+                  <a:tcPr>
                     <a:lnL w="6350" cap="flat" cmpd="sng" algn="ctr">
                       <a:solidFill>
                         <a:srgbClr val="D1DCF0"/>
@@ -2295,7 +2253,7 @@
                     <a:bodyPr/>
                     <a:lstStyle/>
                     <a:p>
-                      <a:pPr algn="ctr" indent="0" marL="0">
+                      <a:pPr marL="0" indent="0" algn="ctr">
                         <a:buNone/>
                       </a:pPr>
                       <a:r>
@@ -2316,7 +2274,7 @@
                       </a:endParaRPr>
                     </a:p>
                   </a:txBody>
-                  <a:tcPr marL="91440" marR="91440" marT="45720" marB="45720">
+                  <a:tcPr>
                     <a:lnL w="6350" cap="flat" cmpd="sng" algn="ctr">
                       <a:solidFill>
                         <a:srgbClr val="D1DCF0"/>
@@ -2363,7 +2321,7 @@
                     <a:bodyPr/>
                     <a:lstStyle/>
                     <a:p>
-                      <a:pPr algn="ctr" indent="0" marL="0">
+                      <a:pPr marL="0" indent="0" algn="ctr">
                         <a:buNone/>
                       </a:pPr>
                       <a:r>
@@ -2384,7 +2342,7 @@
                       </a:endParaRPr>
                     </a:p>
                   </a:txBody>
-                  <a:tcPr marL="91440" marR="91440" marT="45720" marB="45720">
+                  <a:tcPr>
                     <a:lnL w="6350" cap="flat" cmpd="sng" algn="ctr">
                       <a:solidFill>
                         <a:srgbClr val="D1DCF0"/>
@@ -2431,7 +2389,7 @@
                     <a:bodyPr/>
                     <a:lstStyle/>
                     <a:p>
-                      <a:pPr algn="ctr" indent="0" marL="0">
+                      <a:pPr marL="0" indent="0" algn="ctr">
                         <a:buNone/>
                       </a:pPr>
                       <a:r>
@@ -2452,7 +2410,7 @@
                       </a:endParaRPr>
                     </a:p>
                   </a:txBody>
-                  <a:tcPr marL="91440" marR="91440" marT="45720" marB="45720">
+                  <a:tcPr>
                     <a:lnL w="6350" cap="flat" cmpd="sng" algn="ctr">
                       <a:solidFill>
                         <a:srgbClr val="D1DCF0"/>
@@ -2494,6 +2452,11 @@
                     </a:solidFill>
                   </a:tcPr>
                 </a:tc>
+                <a:extLst>
+                  <a:ext uri="{0D108BD9-81ED-4DB2-BD59-A6C34878D82A}">
+                    <a16:rowId xmlns:a16="http://schemas.microsoft.com/office/drawing/2014/main" val="10000"/>
+                  </a:ext>
+                </a:extLst>
               </a:tr>
               <a:tr h="338328">
                 <a:tc>
@@ -2501,7 +2464,7 @@
                     <a:bodyPr/>
                     <a:lstStyle/>
                     <a:p>
-                      <a:pPr algn="ctr" indent="0" marL="0">
+                      <a:pPr marL="0" indent="0" algn="ctr">
                         <a:buNone/>
                       </a:pPr>
                       <a:r>
@@ -2522,7 +2485,7 @@
                       </a:endParaRPr>
                     </a:p>
                     <a:p>
-                      <a:pPr algn="ctr" indent="0" marL="0">
+                      <a:pPr marL="0" indent="0" algn="ctr">
                         <a:buNone/>
                       </a:pPr>
                       <a:r>
@@ -2543,7 +2506,7 @@
                       </a:endParaRPr>
                     </a:p>
                   </a:txBody>
-                  <a:tcPr marL="91440" marR="91440" marT="45720" marB="45720" anchor="ctr">
+                  <a:tcPr anchor="ctr">
                     <a:lnL w="6350" cap="flat" cmpd="sng" algn="ctr">
                       <a:solidFill>
                         <a:srgbClr val="D1DCF0"/>
@@ -2590,7 +2553,7 @@
                     <a:bodyPr/>
                     <a:lstStyle/>
                     <a:p>
-                      <a:pPr algn="ctr" indent="0" marL="0">
+                      <a:pPr marL="0" indent="0" algn="ctr">
                         <a:buNone/>
                       </a:pPr>
                       <a:r>
@@ -2611,7 +2574,7 @@
                       </a:endParaRPr>
                     </a:p>
                   </a:txBody>
-                  <a:tcPr marL="91440" marR="91440" marT="45720" marB="45720" anchor="ctr">
+                  <a:tcPr anchor="ctr">
                     <a:lnL w="6350" cap="flat" cmpd="sng" algn="ctr">
                       <a:solidFill>
                         <a:srgbClr val="D1DCF0"/>
@@ -2658,7 +2621,7 @@
                     <a:bodyPr/>
                     <a:lstStyle/>
                     <a:p>
-                      <a:pPr algn="ctr" indent="0" marL="0">
+                      <a:pPr marL="0" indent="0" algn="ctr">
                         <a:buNone/>
                       </a:pPr>
                       <a:r>
@@ -2679,7 +2642,7 @@
                       </a:endParaRPr>
                     </a:p>
                   </a:txBody>
-                  <a:tcPr marL="91440" marR="91440" marT="45720" marB="45720" anchor="ctr">
+                  <a:tcPr anchor="ctr">
                     <a:lnL w="6350" cap="flat" cmpd="sng" algn="ctr">
                       <a:solidFill>
                         <a:srgbClr val="D1DCF0"/>
@@ -2726,7 +2689,7 @@
                     <a:bodyPr/>
                     <a:lstStyle/>
                     <a:p>
-                      <a:pPr algn="ctr" indent="0" marL="0">
+                      <a:pPr marL="0" indent="0" algn="ctr">
                         <a:buNone/>
                       </a:pPr>
                       <a:r>
@@ -2747,7 +2710,7 @@
                       </a:endParaRPr>
                     </a:p>
                   </a:txBody>
-                  <a:tcPr marL="91440" marR="91440" marT="45720" marB="45720" anchor="ctr">
+                  <a:tcPr anchor="ctr">
                     <a:lnL w="6350" cap="flat" cmpd="sng" algn="ctr">
                       <a:solidFill>
                         <a:srgbClr val="D1DCF0"/>
@@ -2794,7 +2757,7 @@
                     <a:bodyPr/>
                     <a:lstStyle/>
                     <a:p>
-                      <a:pPr algn="ctr" indent="0" marL="0">
+                      <a:pPr marL="0" indent="0" algn="ctr">
                         <a:buNone/>
                       </a:pPr>
                       <a:r>
@@ -2815,7 +2778,7 @@
                       </a:endParaRPr>
                     </a:p>
                   </a:txBody>
-                  <a:tcPr marL="91440" marR="91440" marT="45720" marB="45720" anchor="ctr">
+                  <a:tcPr anchor="ctr">
                     <a:lnL w="6350" cap="flat" cmpd="sng" algn="ctr">
                       <a:solidFill>
                         <a:srgbClr val="D1DCF0"/>
@@ -2862,7 +2825,7 @@
                     <a:bodyPr/>
                     <a:lstStyle/>
                     <a:p>
-                      <a:pPr algn="ctr" indent="0" marL="0">
+                      <a:pPr marL="0" indent="0" algn="ctr">
                         <a:buNone/>
                       </a:pPr>
                       <a:r>
@@ -2883,7 +2846,7 @@
                       </a:endParaRPr>
                     </a:p>
                   </a:txBody>
-                  <a:tcPr marL="91440" marR="91440" marT="45720" marB="45720" anchor="ctr">
+                  <a:tcPr anchor="ctr">
                     <a:lnL w="6350" cap="flat" cmpd="sng" algn="ctr">
                       <a:solidFill>
                         <a:srgbClr val="D1DCF0"/>
@@ -2930,7 +2893,7 @@
                     <a:bodyPr/>
                     <a:lstStyle/>
                     <a:p>
-                      <a:pPr algn="ctr" indent="0" marL="0">
+                      <a:pPr marL="0" indent="0" algn="ctr">
                         <a:buNone/>
                       </a:pPr>
                       <a:r>
@@ -2951,7 +2914,7 @@
                       </a:endParaRPr>
                     </a:p>
                   </a:txBody>
-                  <a:tcPr marL="91440" marR="91440" marT="45720" marB="45720" anchor="ctr">
+                  <a:tcPr anchor="ctr">
                     <a:lnL w="6350" cap="flat" cmpd="sng" algn="ctr">
                       <a:solidFill>
                         <a:srgbClr val="D1DCF0"/>
@@ -2998,7 +2961,7 @@
                     <a:bodyPr/>
                     <a:lstStyle/>
                     <a:p>
-                      <a:pPr algn="ctr" indent="0" marL="0">
+                      <a:pPr marL="0" indent="0" algn="ctr">
                         <a:buNone/>
                       </a:pPr>
                       <a:r>
@@ -3019,7 +2982,7 @@
                       </a:endParaRPr>
                     </a:p>
                   </a:txBody>
-                  <a:tcPr marL="91440" marR="91440" marT="45720" marB="45720" anchor="ctr">
+                  <a:tcPr anchor="ctr">
                     <a:lnL w="6350" cap="flat" cmpd="sng" algn="ctr">
                       <a:solidFill>
                         <a:srgbClr val="D1DCF0"/>
@@ -3066,7 +3029,7 @@
                     <a:bodyPr/>
                     <a:lstStyle/>
                     <a:p>
-                      <a:pPr algn="ctr" indent="0" marL="0">
+                      <a:pPr marL="0" indent="0" algn="ctr">
                         <a:buNone/>
                       </a:pPr>
                       <a:r>
@@ -3087,7 +3050,7 @@
                       </a:endParaRPr>
                     </a:p>
                   </a:txBody>
-                  <a:tcPr marL="91440" marR="91440" marT="45720" marB="45720" anchor="ctr">
+                  <a:tcPr anchor="ctr">
                     <a:lnL w="6350" cap="flat" cmpd="sng" algn="ctr">
                       <a:solidFill>
                         <a:srgbClr val="D1DCF0"/>
@@ -3129,6 +3092,11 @@
                     </a:solidFill>
                   </a:tcPr>
                 </a:tc>
+                <a:extLst>
+                  <a:ext uri="{0D108BD9-81ED-4DB2-BD59-A6C34878D82A}">
+                    <a16:rowId xmlns:a16="http://schemas.microsoft.com/office/drawing/2014/main" val="10001"/>
+                  </a:ext>
+                </a:extLst>
               </a:tr>
               <a:tr h="338328">
                 <a:tc>
@@ -3136,7 +3104,7 @@
                     <a:bodyPr/>
                     <a:lstStyle/>
                     <a:p>
-                      <a:pPr algn="ctr" indent="0" marL="0">
+                      <a:pPr marL="0" indent="0" algn="ctr">
                         <a:buNone/>
                       </a:pPr>
                       <a:r>
@@ -3157,7 +3125,7 @@
                       </a:endParaRPr>
                     </a:p>
                     <a:p>
-                      <a:pPr algn="ctr" indent="0" marL="0">
+                      <a:pPr marL="0" indent="0" algn="ctr">
                         <a:buNone/>
                       </a:pPr>
                       <a:r>
@@ -3178,7 +3146,7 @@
                       </a:endParaRPr>
                     </a:p>
                   </a:txBody>
-                  <a:tcPr marL="91440" marR="91440" marT="45720" marB="45720" anchor="ctr">
+                  <a:tcPr anchor="ctr">
                     <a:lnL w="6350" cap="flat" cmpd="sng" algn="ctr">
                       <a:solidFill>
                         <a:srgbClr val="D1DCF0"/>
@@ -3225,7 +3193,7 @@
                     <a:bodyPr/>
                     <a:lstStyle/>
                     <a:p>
-                      <a:pPr algn="ctr" indent="0" marL="0">
+                      <a:pPr marL="0" indent="0" algn="ctr">
                         <a:buNone/>
                       </a:pPr>
                       <a:r>
@@ -3239,9 +3207,6 @@
                         </a:rPr>
                         <a:t>95</a:t>
                       </a:r>
-                      <a:pPr algn="ctr" indent="0" marL="0">
-                        <a:buNone/>
-                      </a:pPr>
                       <a:r>
                         <a:rPr lang="en-US" sz="650" dirty="0">
                           <a:solidFill>
@@ -3260,7 +3225,7 @@
                       </a:endParaRPr>
                     </a:p>
                   </a:txBody>
-                  <a:tcPr marL="91440" marR="91440" marT="45720" marB="45720" anchor="ctr">
+                  <a:tcPr anchor="ctr">
                     <a:lnL w="6350" cap="flat" cmpd="sng" algn="ctr">
                       <a:solidFill>
                         <a:srgbClr val="D1DCF0"/>
@@ -3307,7 +3272,7 @@
                     <a:bodyPr/>
                     <a:lstStyle/>
                     <a:p>
-                      <a:pPr algn="ctr" indent="0" marL="0">
+                      <a:pPr marL="0" indent="0" algn="ctr">
                         <a:buNone/>
                       </a:pPr>
                       <a:r>
@@ -3321,9 +3286,6 @@
                         </a:rPr>
                         <a:t>5</a:t>
                       </a:r>
-                      <a:pPr algn="ctr" indent="0" marL="0">
-                        <a:buNone/>
-                      </a:pPr>
                       <a:r>
                         <a:rPr lang="en-US" sz="650" dirty="0">
                           <a:solidFill>
@@ -3342,7 +3304,7 @@
                       </a:endParaRPr>
                     </a:p>
                   </a:txBody>
-                  <a:tcPr marL="91440" marR="91440" marT="45720" marB="45720" anchor="ctr">
+                  <a:tcPr anchor="ctr">
                     <a:lnL w="6350" cap="flat" cmpd="sng" algn="ctr">
                       <a:solidFill>
                         <a:srgbClr val="D1DCF0"/>
@@ -3389,7 +3351,7 @@
                     <a:bodyPr/>
                     <a:lstStyle/>
                     <a:p>
-                      <a:pPr algn="ctr" indent="0" marL="0">
+                      <a:pPr marL="0" indent="0" algn="ctr">
                         <a:buNone/>
                       </a:pPr>
                       <a:r>
@@ -3403,9 +3365,6 @@
                         </a:rPr>
                         <a:t>123</a:t>
                       </a:r>
-                      <a:pPr algn="ctr" indent="0" marL="0">
-                        <a:buNone/>
-                      </a:pPr>
                       <a:r>
                         <a:rPr lang="en-US" sz="650" dirty="0">
                           <a:solidFill>
@@ -3424,7 +3383,7 @@
                       </a:endParaRPr>
                     </a:p>
                   </a:txBody>
-                  <a:tcPr marL="91440" marR="91440" marT="45720" marB="45720" anchor="ctr">
+                  <a:tcPr anchor="ctr">
                     <a:lnL w="6350" cap="flat" cmpd="sng" algn="ctr">
                       <a:solidFill>
                         <a:srgbClr val="D1DCF0"/>
@@ -3471,7 +3430,7 @@
                     <a:bodyPr/>
                     <a:lstStyle/>
                     <a:p>
-                      <a:pPr algn="ctr" indent="0" marL="0">
+                      <a:pPr marL="0" indent="0" algn="ctr">
                         <a:buNone/>
                       </a:pPr>
                       <a:r>
@@ -3485,9 +3444,6 @@
                         </a:rPr>
                         <a:t>22</a:t>
                       </a:r>
-                      <a:pPr algn="ctr" indent="0" marL="0">
-                        <a:buNone/>
-                      </a:pPr>
                       <a:r>
                         <a:rPr lang="en-US" sz="650" dirty="0">
                           <a:solidFill>
@@ -3506,7 +3462,7 @@
                       </a:endParaRPr>
                     </a:p>
                   </a:txBody>
-                  <a:tcPr marL="91440" marR="91440" marT="45720" marB="45720" anchor="ctr">
+                  <a:tcPr anchor="ctr">
                     <a:lnL w="6350" cap="flat" cmpd="sng" algn="ctr">
                       <a:solidFill>
                         <a:srgbClr val="D1DCF0"/>
@@ -3553,7 +3509,7 @@
                     <a:bodyPr/>
                     <a:lstStyle/>
                     <a:p>
-                      <a:pPr algn="ctr" indent="0" marL="0">
+                      <a:pPr marL="0" indent="0" algn="ctr">
                         <a:buNone/>
                       </a:pPr>
                       <a:r>
@@ -3567,9 +3523,6 @@
                         </a:rPr>
                         <a:t>6</a:t>
                       </a:r>
-                      <a:pPr algn="ctr" indent="0" marL="0">
-                        <a:buNone/>
-                      </a:pPr>
                       <a:r>
                         <a:rPr lang="en-US" sz="650" dirty="0">
                           <a:solidFill>
@@ -3588,7 +3541,7 @@
                       </a:endParaRPr>
                     </a:p>
                   </a:txBody>
-                  <a:tcPr marL="91440" marR="91440" marT="45720" marB="45720" anchor="ctr">
+                  <a:tcPr anchor="ctr">
                     <a:lnL w="6350" cap="flat" cmpd="sng" algn="ctr">
                       <a:solidFill>
                         <a:srgbClr val="D1DCF0"/>
@@ -3635,7 +3588,7 @@
                     <a:bodyPr/>
                     <a:lstStyle/>
                     <a:p>
-                      <a:pPr algn="ctr" indent="0" marL="0">
+                      <a:pPr marL="0" indent="0" algn="ctr">
                         <a:buNone/>
                       </a:pPr>
                       <a:r>
@@ -3649,9 +3602,6 @@
                         </a:rPr>
                         <a:t>8</a:t>
                       </a:r>
-                      <a:pPr algn="ctr" indent="0" marL="0">
-                        <a:buNone/>
-                      </a:pPr>
                       <a:r>
                         <a:rPr lang="en-US" sz="650" dirty="0">
                           <a:solidFill>
@@ -3670,7 +3620,7 @@
                       </a:endParaRPr>
                     </a:p>
                   </a:txBody>
-                  <a:tcPr marL="91440" marR="91440" marT="45720" marB="45720" anchor="ctr">
+                  <a:tcPr anchor="ctr">
                     <a:lnL w="6350" cap="flat" cmpd="sng" algn="ctr">
                       <a:solidFill>
                         <a:srgbClr val="D1DCF0"/>
@@ -3717,7 +3667,7 @@
                     <a:bodyPr/>
                     <a:lstStyle/>
                     <a:p>
-                      <a:pPr algn="ctr" indent="0" marL="0">
+                      <a:pPr marL="0" indent="0" algn="ctr">
                         <a:buNone/>
                       </a:pPr>
                       <a:r>
@@ -3731,9 +3681,6 @@
                         </a:rPr>
                         <a:t>16</a:t>
                       </a:r>
-                      <a:pPr algn="ctr" indent="0" marL="0">
-                        <a:buNone/>
-                      </a:pPr>
                       <a:r>
                         <a:rPr lang="en-US" sz="650" dirty="0">
                           <a:solidFill>
@@ -3752,7 +3699,7 @@
                       </a:endParaRPr>
                     </a:p>
                   </a:txBody>
-                  <a:tcPr marL="91440" marR="91440" marT="45720" marB="45720" anchor="ctr">
+                  <a:tcPr anchor="ctr">
                     <a:lnL w="6350" cap="flat" cmpd="sng" algn="ctr">
                       <a:solidFill>
                         <a:srgbClr val="D1DCF0"/>
@@ -3799,7 +3746,7 @@
                     <a:bodyPr/>
                     <a:lstStyle/>
                     <a:p>
-                      <a:pPr algn="ctr" indent="0" marL="0">
+                      <a:pPr marL="0" indent="0" algn="ctr">
                         <a:buNone/>
                       </a:pPr>
                       <a:r>
@@ -3813,9 +3760,6 @@
                         </a:rPr>
                         <a:t>275</a:t>
                       </a:r>
-                      <a:pPr algn="ctr" indent="0" marL="0">
-                        <a:buNone/>
-                      </a:pPr>
                       <a:r>
                         <a:rPr lang="en-US" sz="650" dirty="0">
                           <a:solidFill>
@@ -3834,7 +3778,7 @@
                       </a:endParaRPr>
                     </a:p>
                   </a:txBody>
-                  <a:tcPr marL="91440" marR="91440" marT="45720" marB="45720" anchor="ctr">
+                  <a:tcPr anchor="ctr">
                     <a:lnL w="6350" cap="flat" cmpd="sng" algn="ctr">
                       <a:solidFill>
                         <a:srgbClr val="D1DCF0"/>
@@ -3876,6 +3820,11 @@
                     </a:solidFill>
                   </a:tcPr>
                 </a:tc>
+                <a:extLst>
+                  <a:ext uri="{0D108BD9-81ED-4DB2-BD59-A6C34878D82A}">
+                    <a16:rowId xmlns:a16="http://schemas.microsoft.com/office/drawing/2014/main" val="10002"/>
+                  </a:ext>
+                </a:extLst>
               </a:tr>
               <a:tr h="338328">
                 <a:tc>
@@ -3883,7 +3832,7 @@
                     <a:bodyPr/>
                     <a:lstStyle/>
                     <a:p>
-                      <a:pPr algn="ctr" indent="0" marL="0">
+                      <a:pPr marL="0" indent="0" algn="ctr">
                         <a:buNone/>
                       </a:pPr>
                       <a:r>
@@ -3904,7 +3853,7 @@
                       </a:endParaRPr>
                     </a:p>
                     <a:p>
-                      <a:pPr algn="ctr" indent="0" marL="0">
+                      <a:pPr marL="0" indent="0" algn="ctr">
                         <a:buNone/>
                       </a:pPr>
                       <a:r>
@@ -3925,7 +3874,7 @@
                       </a:endParaRPr>
                     </a:p>
                   </a:txBody>
-                  <a:tcPr marL="91440" marR="91440" marT="45720" marB="45720" anchor="ctr">
+                  <a:tcPr anchor="ctr">
                     <a:lnL w="6350" cap="flat" cmpd="sng" algn="ctr">
                       <a:solidFill>
                         <a:srgbClr val="D1DCF0"/>
@@ -3972,7 +3921,7 @@
                     <a:bodyPr/>
                     <a:lstStyle/>
                     <a:p>
-                      <a:pPr algn="ctr" indent="0" marL="0">
+                      <a:pPr marL="0" indent="0" algn="ctr">
                         <a:buNone/>
                       </a:pPr>
                       <a:r>
@@ -3993,7 +3942,7 @@
                       </a:endParaRPr>
                     </a:p>
                   </a:txBody>
-                  <a:tcPr marL="91440" marR="91440" marT="45720" marB="45720" anchor="ctr">
+                  <a:tcPr anchor="ctr">
                     <a:lnL w="6350" cap="flat" cmpd="sng" algn="ctr">
                       <a:solidFill>
                         <a:srgbClr val="D1DCF0"/>
@@ -4040,7 +3989,7 @@
                     <a:bodyPr/>
                     <a:lstStyle/>
                     <a:p>
-                      <a:pPr algn="ctr" indent="0" marL="0">
+                      <a:pPr marL="0" indent="0" algn="ctr">
                         <a:buNone/>
                       </a:pPr>
                       <a:r>
@@ -4054,9 +4003,6 @@
                         </a:rPr>
                         <a:t>6</a:t>
                       </a:r>
-                      <a:pPr algn="ctr" indent="0" marL="0">
-                        <a:buNone/>
-                      </a:pPr>
                       <a:r>
                         <a:rPr lang="en-US" sz="650" dirty="0">
                           <a:solidFill>
@@ -4075,7 +4021,7 @@
                       </a:endParaRPr>
                     </a:p>
                   </a:txBody>
-                  <a:tcPr marL="91440" marR="91440" marT="45720" marB="45720" anchor="ctr">
+                  <a:tcPr anchor="ctr">
                     <a:lnL w="6350" cap="flat" cmpd="sng" algn="ctr">
                       <a:solidFill>
                         <a:srgbClr val="D1DCF0"/>
@@ -4122,7 +4068,7 @@
                     <a:bodyPr/>
                     <a:lstStyle/>
                     <a:p>
-                      <a:pPr algn="ctr" indent="0" marL="0">
+                      <a:pPr marL="0" indent="0" algn="ctr">
                         <a:buNone/>
                       </a:pPr>
                       <a:r>
@@ -4136,9 +4082,6 @@
                         </a:rPr>
                         <a:t>44</a:t>
                       </a:r>
-                      <a:pPr algn="ctr" indent="0" marL="0">
-                        <a:buNone/>
-                      </a:pPr>
                       <a:r>
                         <a:rPr lang="en-US" sz="650" dirty="0">
                           <a:solidFill>
@@ -4157,7 +4100,7 @@
                       </a:endParaRPr>
                     </a:p>
                   </a:txBody>
-                  <a:tcPr marL="91440" marR="91440" marT="45720" marB="45720" anchor="ctr">
+                  <a:tcPr anchor="ctr">
                     <a:lnL w="6350" cap="flat" cmpd="sng" algn="ctr">
                       <a:solidFill>
                         <a:srgbClr val="D1DCF0"/>
@@ -4204,7 +4147,7 @@
                     <a:bodyPr/>
                     <a:lstStyle/>
                     <a:p>
-                      <a:pPr algn="ctr" indent="0" marL="0">
+                      <a:pPr marL="0" indent="0" algn="ctr">
                         <a:buNone/>
                       </a:pPr>
                       <a:r>
@@ -4218,9 +4161,6 @@
                         </a:rPr>
                         <a:t>19</a:t>
                       </a:r>
-                      <a:pPr algn="ctr" indent="0" marL="0">
-                        <a:buNone/>
-                      </a:pPr>
                       <a:r>
                         <a:rPr lang="en-US" sz="650" dirty="0">
                           <a:solidFill>
@@ -4239,7 +4179,7 @@
                       </a:endParaRPr>
                     </a:p>
                   </a:txBody>
-                  <a:tcPr marL="91440" marR="91440" marT="45720" marB="45720" anchor="ctr">
+                  <a:tcPr anchor="ctr">
                     <a:lnL w="6350" cap="flat" cmpd="sng" algn="ctr">
                       <a:solidFill>
                         <a:srgbClr val="D1DCF0"/>
@@ -4286,7 +4226,7 @@
                     <a:bodyPr/>
                     <a:lstStyle/>
                     <a:p>
-                      <a:pPr algn="ctr" indent="0" marL="0">
+                      <a:pPr marL="0" indent="0" algn="ctr">
                         <a:buNone/>
                       </a:pPr>
                       <a:r>
@@ -4300,9 +4240,6 @@
                         </a:rPr>
                         <a:t>13</a:t>
                       </a:r>
-                      <a:pPr algn="ctr" indent="0" marL="0">
-                        <a:buNone/>
-                      </a:pPr>
                       <a:r>
                         <a:rPr lang="en-US" sz="650" dirty="0">
                           <a:solidFill>
@@ -4321,7 +4258,7 @@
                       </a:endParaRPr>
                     </a:p>
                   </a:txBody>
-                  <a:tcPr marL="91440" marR="91440" marT="45720" marB="45720" anchor="ctr">
+                  <a:tcPr anchor="ctr">
                     <a:lnL w="6350" cap="flat" cmpd="sng" algn="ctr">
                       <a:solidFill>
                         <a:srgbClr val="D1DCF0"/>
@@ -4368,7 +4305,7 @@
                     <a:bodyPr/>
                     <a:lstStyle/>
                     <a:p>
-                      <a:pPr algn="ctr" indent="0" marL="0">
+                      <a:pPr marL="0" indent="0" algn="ctr">
                         <a:buNone/>
                       </a:pPr>
                       <a:r>
@@ -4382,9 +4319,6 @@
                         </a:rPr>
                         <a:t>3</a:t>
                       </a:r>
-                      <a:pPr algn="ctr" indent="0" marL="0">
-                        <a:buNone/>
-                      </a:pPr>
                       <a:r>
                         <a:rPr lang="en-US" sz="650" dirty="0">
                           <a:solidFill>
@@ -4403,7 +4337,7 @@
                       </a:endParaRPr>
                     </a:p>
                   </a:txBody>
-                  <a:tcPr marL="91440" marR="91440" marT="45720" marB="45720" anchor="ctr">
+                  <a:tcPr anchor="ctr">
                     <a:lnL w="6350" cap="flat" cmpd="sng" algn="ctr">
                       <a:solidFill>
                         <a:srgbClr val="D1DCF0"/>
@@ -4450,7 +4384,7 @@
                     <a:bodyPr/>
                     <a:lstStyle/>
                     <a:p>
-                      <a:pPr algn="ctr" indent="0" marL="0">
+                      <a:pPr marL="0" indent="0" algn="ctr">
                         <a:buNone/>
                       </a:pPr>
                       <a:r>
@@ -4464,9 +4398,6 @@
                         </a:rPr>
                         <a:t>11</a:t>
                       </a:r>
-                      <a:pPr algn="ctr" indent="0" marL="0">
-                        <a:buNone/>
-                      </a:pPr>
                       <a:r>
                         <a:rPr lang="en-US" sz="650" dirty="0">
                           <a:solidFill>
@@ -4485,7 +4416,7 @@
                       </a:endParaRPr>
                     </a:p>
                   </a:txBody>
-                  <a:tcPr marL="91440" marR="91440" marT="45720" marB="45720" anchor="ctr">
+                  <a:tcPr anchor="ctr">
                     <a:lnL w="6350" cap="flat" cmpd="sng" algn="ctr">
                       <a:solidFill>
                         <a:srgbClr val="D1DCF0"/>
@@ -4532,7 +4463,7 @@
                     <a:bodyPr/>
                     <a:lstStyle/>
                     <a:p>
-                      <a:pPr algn="ctr" indent="0" marL="0">
+                      <a:pPr marL="0" indent="0" algn="ctr">
                         <a:buNone/>
                       </a:pPr>
                       <a:r>
@@ -4546,9 +4477,6 @@
                         </a:rPr>
                         <a:t>168</a:t>
                       </a:r>
-                      <a:pPr algn="ctr" indent="0" marL="0">
-                        <a:buNone/>
-                      </a:pPr>
                       <a:r>
                         <a:rPr lang="en-US" sz="650" dirty="0">
                           <a:solidFill>
@@ -4567,7 +4495,7 @@
                       </a:endParaRPr>
                     </a:p>
                   </a:txBody>
-                  <a:tcPr marL="91440" marR="91440" marT="45720" marB="45720" anchor="ctr">
+                  <a:tcPr anchor="ctr">
                     <a:lnL w="6350" cap="flat" cmpd="sng" algn="ctr">
                       <a:solidFill>
                         <a:srgbClr val="D1DCF0"/>
@@ -4609,6 +4537,11 @@
                     </a:solidFill>
                   </a:tcPr>
                 </a:tc>
+                <a:extLst>
+                  <a:ext uri="{0D108BD9-81ED-4DB2-BD59-A6C34878D82A}">
+                    <a16:rowId xmlns:a16="http://schemas.microsoft.com/office/drawing/2014/main" val="10003"/>
+                  </a:ext>
+                </a:extLst>
               </a:tr>
               <a:tr h="338328">
                 <a:tc>
@@ -4616,7 +4549,7 @@
                     <a:bodyPr/>
                     <a:lstStyle/>
                     <a:p>
-                      <a:pPr algn="ctr" indent="0" marL="0">
+                      <a:pPr marL="0" indent="0" algn="ctr">
                         <a:buNone/>
                       </a:pPr>
                       <a:r>
@@ -4637,7 +4570,7 @@
                       </a:endParaRPr>
                     </a:p>
                     <a:p>
-                      <a:pPr algn="ctr" indent="0" marL="0">
+                      <a:pPr marL="0" indent="0" algn="ctr">
                         <a:buNone/>
                       </a:pPr>
                       <a:r>
@@ -4658,7 +4591,7 @@
                       </a:endParaRPr>
                     </a:p>
                   </a:txBody>
-                  <a:tcPr marL="91440" marR="91440" marT="45720" marB="45720" anchor="ctr">
+                  <a:tcPr anchor="ctr">
                     <a:lnL w="6350" cap="flat" cmpd="sng" algn="ctr">
                       <a:solidFill>
                         <a:srgbClr val="D1DCF0"/>
@@ -4705,7 +4638,7 @@
                     <a:bodyPr/>
                     <a:lstStyle/>
                     <a:p>
-                      <a:pPr algn="ctr" indent="0" marL="0">
+                      <a:pPr marL="0" indent="0" algn="ctr">
                         <a:buNone/>
                       </a:pPr>
                       <a:r>
@@ -4719,9 +4652,6 @@
                         </a:rPr>
                         <a:t>89</a:t>
                       </a:r>
-                      <a:pPr algn="ctr" indent="0" marL="0">
-                        <a:buNone/>
-                      </a:pPr>
                       <a:r>
                         <a:rPr lang="en-US" sz="650" dirty="0">
                           <a:solidFill>
@@ -4740,7 +4670,7 @@
                       </a:endParaRPr>
                     </a:p>
                   </a:txBody>
-                  <a:tcPr marL="91440" marR="91440" marT="45720" marB="45720" anchor="ctr">
+                  <a:tcPr anchor="ctr">
                     <a:lnL w="6350" cap="flat" cmpd="sng" algn="ctr">
                       <a:solidFill>
                         <a:srgbClr val="D1DCF0"/>
@@ -4787,7 +4717,7 @@
                     <a:bodyPr/>
                     <a:lstStyle/>
                     <a:p>
-                      <a:pPr algn="ctr" indent="0" marL="0">
+                      <a:pPr marL="0" indent="0" algn="ctr">
                         <a:buNone/>
                       </a:pPr>
                       <a:r>
@@ -4801,9 +4731,6 @@
                         </a:rPr>
                         <a:t>8</a:t>
                       </a:r>
-                      <a:pPr algn="ctr" indent="0" marL="0">
-                        <a:buNone/>
-                      </a:pPr>
                       <a:r>
                         <a:rPr lang="en-US" sz="650" dirty="0">
                           <a:solidFill>
@@ -4822,7 +4749,7 @@
                       </a:endParaRPr>
                     </a:p>
                   </a:txBody>
-                  <a:tcPr marL="91440" marR="91440" marT="45720" marB="45720" anchor="ctr">
+                  <a:tcPr anchor="ctr">
                     <a:lnL w="6350" cap="flat" cmpd="sng" algn="ctr">
                       <a:solidFill>
                         <a:srgbClr val="D1DCF0"/>
@@ -4869,7 +4796,7 @@
                     <a:bodyPr/>
                     <a:lstStyle/>
                     <a:p>
-                      <a:pPr algn="ctr" indent="0" marL="0">
+                      <a:pPr marL="0" indent="0" algn="ctr">
                         <a:buNone/>
                       </a:pPr>
                       <a:r>
@@ -4883,9 +4810,6 @@
                         </a:rPr>
                         <a:t>11</a:t>
                       </a:r>
-                      <a:pPr algn="ctr" indent="0" marL="0">
-                        <a:buNone/>
-                      </a:pPr>
                       <a:r>
                         <a:rPr lang="en-US" sz="650" dirty="0">
                           <a:solidFill>
@@ -4904,7 +4828,7 @@
                       </a:endParaRPr>
                     </a:p>
                   </a:txBody>
-                  <a:tcPr marL="91440" marR="91440" marT="45720" marB="45720" anchor="ctr">
+                  <a:tcPr anchor="ctr">
                     <a:lnL w="6350" cap="flat" cmpd="sng" algn="ctr">
                       <a:solidFill>
                         <a:srgbClr val="D1DCF0"/>
@@ -4951,7 +4875,7 @@
                     <a:bodyPr/>
                     <a:lstStyle/>
                     <a:p>
-                      <a:pPr algn="ctr" indent="0" marL="0">
+                      <a:pPr marL="0" indent="0" algn="ctr">
                         <a:buNone/>
                       </a:pPr>
                       <a:r>
@@ -4965,9 +4889,6 @@
                         </a:rPr>
                         <a:t>45</a:t>
                       </a:r>
-                      <a:pPr algn="ctr" indent="0" marL="0">
-                        <a:buNone/>
-                      </a:pPr>
                       <a:r>
                         <a:rPr lang="en-US" sz="650" dirty="0">
                           <a:solidFill>
@@ -4986,7 +4907,7 @@
                       </a:endParaRPr>
                     </a:p>
                   </a:txBody>
-                  <a:tcPr marL="91440" marR="91440" marT="45720" marB="45720" anchor="ctr">
+                  <a:tcPr anchor="ctr">
                     <a:lnL w="6350" cap="flat" cmpd="sng" algn="ctr">
                       <a:solidFill>
                         <a:srgbClr val="D1DCF0"/>
@@ -5033,7 +4954,7 @@
                     <a:bodyPr/>
                     <a:lstStyle/>
                     <a:p>
-                      <a:pPr algn="ctr" indent="0" marL="0">
+                      <a:pPr marL="0" indent="0" algn="ctr">
                         <a:buNone/>
                       </a:pPr>
                       <a:r>
@@ -5047,9 +4968,6 @@
                         </a:rPr>
                         <a:t>7</a:t>
                       </a:r>
-                      <a:pPr algn="ctr" indent="0" marL="0">
-                        <a:buNone/>
-                      </a:pPr>
                       <a:r>
                         <a:rPr lang="en-US" sz="650" dirty="0">
                           <a:solidFill>
@@ -5068,7 +4986,7 @@
                       </a:endParaRPr>
                     </a:p>
                   </a:txBody>
-                  <a:tcPr marL="91440" marR="91440" marT="45720" marB="45720" anchor="ctr">
+                  <a:tcPr anchor="ctr">
                     <a:lnL w="6350" cap="flat" cmpd="sng" algn="ctr">
                       <a:solidFill>
                         <a:srgbClr val="D1DCF0"/>
@@ -5115,7 +5033,7 @@
                     <a:bodyPr/>
                     <a:lstStyle/>
                     <a:p>
-                      <a:pPr algn="ctr" indent="0" marL="0">
+                      <a:pPr marL="0" indent="0" algn="ctr">
                         <a:buNone/>
                       </a:pPr>
                       <a:r>
@@ -5129,9 +5047,6 @@
                         </a:rPr>
                         <a:t>8</a:t>
                       </a:r>
-                      <a:pPr algn="ctr" indent="0" marL="0">
-                        <a:buNone/>
-                      </a:pPr>
                       <a:r>
                         <a:rPr lang="en-US" sz="650" dirty="0">
                           <a:solidFill>
@@ -5150,7 +5065,7 @@
                       </a:endParaRPr>
                     </a:p>
                   </a:txBody>
-                  <a:tcPr marL="91440" marR="91440" marT="45720" marB="45720" anchor="ctr">
+                  <a:tcPr anchor="ctr">
                     <a:lnL w="6350" cap="flat" cmpd="sng" algn="ctr">
                       <a:solidFill>
                         <a:srgbClr val="D1DCF0"/>
@@ -5197,7 +5112,7 @@
                     <a:bodyPr/>
                     <a:lstStyle/>
                     <a:p>
-                      <a:pPr algn="ctr" indent="0" marL="0">
+                      <a:pPr marL="0" indent="0" algn="ctr">
                         <a:buNone/>
                       </a:pPr>
                       <a:r>
@@ -5211,9 +5126,6 @@
                         </a:rPr>
                         <a:t>18</a:t>
                       </a:r>
-                      <a:pPr algn="ctr" indent="0" marL="0">
-                        <a:buNone/>
-                      </a:pPr>
                       <a:r>
                         <a:rPr lang="en-US" sz="650" dirty="0">
                           <a:solidFill>
@@ -5232,7 +5144,7 @@
                       </a:endParaRPr>
                     </a:p>
                   </a:txBody>
-                  <a:tcPr marL="91440" marR="91440" marT="45720" marB="45720" anchor="ctr">
+                  <a:tcPr anchor="ctr">
                     <a:lnL w="6350" cap="flat" cmpd="sng" algn="ctr">
                       <a:solidFill>
                         <a:srgbClr val="D1DCF0"/>
@@ -5279,7 +5191,7 @@
                     <a:bodyPr/>
                     <a:lstStyle/>
                     <a:p>
-                      <a:pPr algn="ctr" indent="0" marL="0">
+                      <a:pPr marL="0" indent="0" algn="ctr">
                         <a:buNone/>
                       </a:pPr>
                       <a:r>
@@ -5293,9 +5205,6 @@
                         </a:rPr>
                         <a:t>132</a:t>
                       </a:r>
-                      <a:pPr algn="ctr" indent="0" marL="0">
-                        <a:buNone/>
-                      </a:pPr>
                       <a:r>
                         <a:rPr lang="en-US" sz="650" dirty="0">
                           <a:solidFill>
@@ -5314,7 +5223,7 @@
                       </a:endParaRPr>
                     </a:p>
                   </a:txBody>
-                  <a:tcPr marL="91440" marR="91440" marT="45720" marB="45720" anchor="ctr">
+                  <a:tcPr anchor="ctr">
                     <a:lnL w="6350" cap="flat" cmpd="sng" algn="ctr">
                       <a:solidFill>
                         <a:srgbClr val="D1DCF0"/>
@@ -5356,6 +5265,11 @@
                     </a:solidFill>
                   </a:tcPr>
                 </a:tc>
+                <a:extLst>
+                  <a:ext uri="{0D108BD9-81ED-4DB2-BD59-A6C34878D82A}">
+                    <a16:rowId xmlns:a16="http://schemas.microsoft.com/office/drawing/2014/main" val="10004"/>
+                  </a:ext>
+                </a:extLst>
               </a:tr>
             </a:tbl>
           </a:graphicData>
@@ -5380,6 +5294,13 @@
           </a:solidFill>
           <a:ln/>
         </p:spPr>
+        <p:txBody>
+          <a:bodyPr/>
+          <a:lstStyle/>
+          <a:p>
+            <a:endParaRPr lang="zh-TW" altLang="en-US"/>
+          </a:p>
+        </p:txBody>
       </p:sp>
       <p:sp>
         <p:nvSpPr>
@@ -5402,7 +5323,7 @@
           <a:bodyPr wrap="square" rtlCol="0" anchor="ctr"/>
           <a:lstStyle/>
           <a:p>
-            <a:pPr indent="0" marL="0">
+            <a:pPr marL="0" indent="0">
               <a:buNone/>
             </a:pPr>
             <a:r>
@@ -5422,7 +5343,7 @@
       </p:sp>
       <p:graphicFrame>
         <p:nvGraphicFramePr>
-          <p:cNvPr id="8" name="Chart 0" descr=""/>
+          <p:cNvPr id="8" name="Chart 0"/>
           <p:cNvGraphicFramePr/>
           <p:nvPr/>
         </p:nvGraphicFramePr>
@@ -5430,9 +5351,9 @@
           <a:off x="64008" y="2642616"/>
           <a:ext cx="3529584" cy="2340864"/>
         </p:xfrm>
-        <a:graphic xmlns:a="http://schemas.openxmlformats.org/drawingml/2006/main">
+        <a:graphic>
           <a:graphicData uri="http://schemas.openxmlformats.org/drawingml/2006/chart">
-            <c:chart xmlns:c="http://schemas.openxmlformats.org/drawingml/2006/chart" r:id="rId1"/>
+            <c:chart xmlns:c="http://schemas.openxmlformats.org/drawingml/2006/chart" xmlns:r="http://schemas.openxmlformats.org/officeDocument/2006/relationships" r:id="rId3"/>
           </a:graphicData>
         </a:graphic>
       </p:graphicFrame>
@@ -5455,6 +5376,13 @@
           </a:solidFill>
           <a:ln/>
         </p:spPr>
+        <p:txBody>
+          <a:bodyPr/>
+          <a:lstStyle/>
+          <a:p>
+            <a:endParaRPr lang="zh-TW" altLang="en-US"/>
+          </a:p>
+        </p:txBody>
       </p:sp>
       <p:sp>
         <p:nvSpPr>
@@ -5477,7 +5405,7 @@
           <a:bodyPr wrap="square" rtlCol="0" anchor="ctr"/>
           <a:lstStyle/>
           <a:p>
-            <a:pPr indent="0" marL="0">
+            <a:pPr marL="0" indent="0">
               <a:buNone/>
             </a:pPr>
             <a:r>
@@ -5516,7 +5444,7 @@
           <a:bodyPr wrap="square" rtlCol="0" anchor="ctr"/>
           <a:lstStyle/>
           <a:p>
-            <a:pPr indent="0" marL="0">
+            <a:pPr marL="0" indent="0">
               <a:buNone/>
             </a:pPr>
             <a:r>
@@ -5553,6 +5481,13 @@
           </a:solidFill>
           <a:ln/>
         </p:spPr>
+        <p:txBody>
+          <a:bodyPr/>
+          <a:lstStyle/>
+          <a:p>
+            <a:endParaRPr lang="zh-TW" altLang="en-US"/>
+          </a:p>
+        </p:txBody>
       </p:sp>
       <p:sp>
         <p:nvSpPr>
@@ -5575,7 +5510,7 @@
           <a:bodyPr wrap="square" rtlCol="0" anchor="ctr"/>
           <a:lstStyle/>
           <a:p>
-            <a:pPr indent="0" marL="0">
+            <a:pPr marL="0" indent="0">
               <a:buNone/>
             </a:pPr>
             <a:r>
@@ -5614,7 +5549,7 @@
           <a:bodyPr wrap="square" rtlCol="0" anchor="ctr"/>
           <a:lstStyle/>
           <a:p>
-            <a:pPr indent="0" marL="0">
+            <a:pPr marL="0" indent="0">
               <a:buNone/>
             </a:pPr>
             <a:r>
@@ -5651,6 +5586,13 @@
           </a:solidFill>
           <a:ln/>
         </p:spPr>
+        <p:txBody>
+          <a:bodyPr/>
+          <a:lstStyle/>
+          <a:p>
+            <a:endParaRPr lang="zh-TW" altLang="en-US"/>
+          </a:p>
+        </p:txBody>
       </p:sp>
       <p:sp>
         <p:nvSpPr>
@@ -5673,7 +5615,7 @@
           <a:bodyPr wrap="square" rtlCol="0" anchor="ctr"/>
           <a:lstStyle/>
           <a:p>
-            <a:pPr indent="0" marL="0">
+            <a:pPr marL="0" indent="0">
               <a:buNone/>
             </a:pPr>
             <a:r>
@@ -5712,7 +5654,7 @@
           <a:bodyPr wrap="square" rtlCol="0" anchor="ctr"/>
           <a:lstStyle/>
           <a:p>
-            <a:pPr indent="0" marL="0">
+            <a:pPr marL="0" indent="0">
               <a:buNone/>
             </a:pPr>
             <a:r>
@@ -5749,6 +5691,13 @@
           </a:solidFill>
           <a:ln/>
         </p:spPr>
+        <p:txBody>
+          <a:bodyPr/>
+          <a:lstStyle/>
+          <a:p>
+            <a:endParaRPr lang="zh-TW" altLang="en-US"/>
+          </a:p>
+        </p:txBody>
       </p:sp>
       <p:sp>
         <p:nvSpPr>
@@ -5771,7 +5720,7 @@
           <a:bodyPr wrap="square" rtlCol="0" anchor="ctr"/>
           <a:lstStyle/>
           <a:p>
-            <a:pPr indent="0" marL="0">
+            <a:pPr marL="0" indent="0">
               <a:buNone/>
             </a:pPr>
             <a:r>
@@ -5810,7 +5759,7 @@
           <a:bodyPr wrap="square" rtlCol="0" anchor="ctr"/>
           <a:lstStyle/>
           <a:p>
-            <a:pPr indent="0" marL="0">
+            <a:pPr marL="0" indent="0">
               <a:buNone/>
             </a:pPr>
             <a:r>
@@ -5847,6 +5796,13 @@
           </a:solidFill>
           <a:ln/>
         </p:spPr>
+        <p:txBody>
+          <a:bodyPr/>
+          <a:lstStyle/>
+          <a:p>
+            <a:endParaRPr lang="zh-TW" altLang="en-US"/>
+          </a:p>
+        </p:txBody>
       </p:sp>
       <p:sp>
         <p:nvSpPr>
@@ -5869,7 +5825,7 @@
           <a:bodyPr wrap="square" rtlCol="0" anchor="ctr"/>
           <a:lstStyle/>
           <a:p>
-            <a:pPr indent="0" marL="0">
+            <a:pPr marL="0" indent="0">
               <a:buNone/>
             </a:pPr>
             <a:r>
@@ -5908,7 +5864,7 @@
           <a:bodyPr wrap="square" rtlCol="0" anchor="ctr"/>
           <a:lstStyle/>
           <a:p>
-            <a:pPr indent="0" marL="0">
+            <a:pPr marL="0" indent="0">
               <a:buNone/>
             </a:pPr>
             <a:r>
@@ -5945,6 +5901,13 @@
           </a:solidFill>
           <a:ln/>
         </p:spPr>
+        <p:txBody>
+          <a:bodyPr/>
+          <a:lstStyle/>
+          <a:p>
+            <a:endParaRPr lang="zh-TW" altLang="en-US"/>
+          </a:p>
+        </p:txBody>
       </p:sp>
       <p:sp>
         <p:nvSpPr>
@@ -5967,7 +5930,7 @@
           <a:bodyPr wrap="square" rtlCol="0" anchor="ctr"/>
           <a:lstStyle/>
           <a:p>
-            <a:pPr indent="0" marL="0">
+            <a:pPr marL="0" indent="0">
               <a:buNone/>
             </a:pPr>
             <a:r>
@@ -6006,7 +5969,7 @@
           <a:bodyPr wrap="square" rtlCol="0" anchor="ctr"/>
           <a:lstStyle/>
           <a:p>
-            <a:pPr indent="0" marL="0">
+            <a:pPr marL="0" indent="0">
               <a:buNone/>
             </a:pPr>
             <a:r>
@@ -6048,6 +6011,13 @@
             <a:prstDash val="solid"/>
           </a:ln>
         </p:spPr>
+        <p:txBody>
+          <a:bodyPr/>
+          <a:lstStyle/>
+          <a:p>
+            <a:endParaRPr lang="zh-TW" altLang="en-US"/>
+          </a:p>
+        </p:txBody>
       </p:sp>
       <p:sp>
         <p:nvSpPr>
@@ -6068,6 +6038,13 @@
           </a:solidFill>
           <a:ln/>
         </p:spPr>
+        <p:txBody>
+          <a:bodyPr/>
+          <a:lstStyle/>
+          <a:p>
+            <a:endParaRPr lang="zh-TW" altLang="en-US"/>
+          </a:p>
+        </p:txBody>
       </p:sp>
       <p:sp>
         <p:nvSpPr>
@@ -6090,7 +6067,7 @@
           <a:bodyPr wrap="square" rtlCol="0" anchor="ctr"/>
           <a:lstStyle/>
           <a:p>
-            <a:pPr indent="0" marL="0">
+            <a:pPr marL="0" indent="0">
               <a:buNone/>
             </a:pPr>
             <a:r>
@@ -6129,7 +6106,7 @@
           <a:bodyPr wrap="square" rtlCol="0" anchor="ctr"/>
           <a:lstStyle/>
           <a:p>
-            <a:pPr indent="0" marL="0">
+            <a:pPr marL="0" indent="0">
               <a:buNone/>
             </a:pPr>
             <a:r>
@@ -6168,7 +6145,7 @@
           <a:bodyPr wrap="square" rtlCol="0" anchor="ctr"/>
           <a:lstStyle/>
           <a:p>
-            <a:pPr indent="0" marL="0">
+            <a:pPr marL="0" indent="0">
               <a:buNone/>
             </a:pPr>
             <a:r>
@@ -6207,7 +6184,7 @@
           <a:bodyPr wrap="square" rtlCol="0" anchor="t"/>
           <a:lstStyle/>
           <a:p>
-            <a:pPr indent="0" marL="0">
+            <a:pPr marL="0" indent="0">
               <a:buNone/>
             </a:pPr>
             <a:endParaRPr lang="en-US" sz="600" dirty="0"/>
@@ -6233,6 +6210,13 @@
           </a:solidFill>
           <a:ln/>
         </p:spPr>
+        <p:txBody>
+          <a:bodyPr/>
+          <a:lstStyle/>
+          <a:p>
+            <a:endParaRPr lang="zh-TW" altLang="en-US"/>
+          </a:p>
+        </p:txBody>
       </p:sp>
       <p:sp>
         <p:nvSpPr>
@@ -6253,6 +6237,13 @@
           </a:solidFill>
           <a:ln/>
         </p:spPr>
+        <p:txBody>
+          <a:bodyPr/>
+          <a:lstStyle/>
+          <a:p>
+            <a:endParaRPr lang="zh-TW" altLang="en-US"/>
+          </a:p>
+        </p:txBody>
       </p:sp>
       <p:sp>
         <p:nvSpPr>
@@ -6278,6 +6269,13 @@
             <a:prstDash val="solid"/>
           </a:ln>
         </p:spPr>
+        <p:txBody>
+          <a:bodyPr/>
+          <a:lstStyle/>
+          <a:p>
+            <a:endParaRPr lang="zh-TW" altLang="en-US"/>
+          </a:p>
+        </p:txBody>
       </p:sp>
       <p:sp>
         <p:nvSpPr>
@@ -6298,6 +6296,13 @@
           </a:solidFill>
           <a:ln/>
         </p:spPr>
+        <p:txBody>
+          <a:bodyPr/>
+          <a:lstStyle/>
+          <a:p>
+            <a:endParaRPr lang="zh-TW" altLang="en-US"/>
+          </a:p>
+        </p:txBody>
       </p:sp>
       <p:sp>
         <p:nvSpPr>
@@ -6320,7 +6325,7 @@
           <a:bodyPr wrap="square" rtlCol="0" anchor="ctr"/>
           <a:lstStyle/>
           <a:p>
-            <a:pPr indent="0" marL="0">
+            <a:pPr marL="0" indent="0">
               <a:buNone/>
             </a:pPr>
             <a:r>
@@ -6359,7 +6364,7 @@
           <a:bodyPr wrap="square" rtlCol="0" anchor="ctr"/>
           <a:lstStyle/>
           <a:p>
-            <a:pPr indent="0" marL="0">
+            <a:pPr marL="0" indent="0">
               <a:buNone/>
             </a:pPr>
             <a:r>
@@ -6398,7 +6403,7 @@
           <a:bodyPr wrap="square" rtlCol="0" anchor="ctr"/>
           <a:lstStyle/>
           <a:p>
-            <a:pPr indent="0" marL="0">
+            <a:pPr marL="0" indent="0">
               <a:buNone/>
             </a:pPr>
             <a:r>
@@ -6437,7 +6442,7 @@
           <a:bodyPr wrap="square" rtlCol="0" anchor="t"/>
           <a:lstStyle/>
           <a:p>
-            <a:pPr indent="0" marL="0">
+            <a:pPr marL="0" indent="0">
               <a:buNone/>
             </a:pPr>
             <a:endParaRPr lang="en-US" sz="600" dirty="0"/>
@@ -6463,6 +6468,13 @@
           </a:solidFill>
           <a:ln/>
         </p:spPr>
+        <p:txBody>
+          <a:bodyPr/>
+          <a:lstStyle/>
+          <a:p>
+            <a:endParaRPr lang="zh-TW" altLang="en-US"/>
+          </a:p>
+        </p:txBody>
       </p:sp>
       <p:sp>
         <p:nvSpPr>
@@ -6483,6 +6495,13 @@
           </a:solidFill>
           <a:ln/>
         </p:spPr>
+        <p:txBody>
+          <a:bodyPr/>
+          <a:lstStyle/>
+          <a:p>
+            <a:endParaRPr lang="zh-TW" altLang="en-US"/>
+          </a:p>
+        </p:txBody>
       </p:sp>
       <p:sp>
         <p:nvSpPr>
@@ -6508,6 +6527,13 @@
             <a:prstDash val="solid"/>
           </a:ln>
         </p:spPr>
+        <p:txBody>
+          <a:bodyPr/>
+          <a:lstStyle/>
+          <a:p>
+            <a:endParaRPr lang="zh-TW" altLang="en-US"/>
+          </a:p>
+        </p:txBody>
       </p:sp>
       <p:sp>
         <p:nvSpPr>
@@ -6528,6 +6554,13 @@
           </a:solidFill>
           <a:ln/>
         </p:spPr>
+        <p:txBody>
+          <a:bodyPr/>
+          <a:lstStyle/>
+          <a:p>
+            <a:endParaRPr lang="zh-TW" altLang="en-US"/>
+          </a:p>
+        </p:txBody>
       </p:sp>
       <p:sp>
         <p:nvSpPr>
@@ -6550,7 +6583,7 @@
           <a:bodyPr wrap="square" rtlCol="0" anchor="ctr"/>
           <a:lstStyle/>
           <a:p>
-            <a:pPr indent="0" marL="0">
+            <a:pPr marL="0" indent="0">
               <a:buNone/>
             </a:pPr>
             <a:r>
@@ -6589,7 +6622,7 @@
           <a:bodyPr wrap="square" rtlCol="0" anchor="ctr"/>
           <a:lstStyle/>
           <a:p>
-            <a:pPr indent="0" marL="0">
+            <a:pPr marL="0" indent="0">
               <a:buNone/>
             </a:pPr>
             <a:r>
@@ -6628,7 +6661,7 @@
           <a:bodyPr wrap="square" rtlCol="0" anchor="ctr"/>
           <a:lstStyle/>
           <a:p>
-            <a:pPr indent="0" marL="0">
+            <a:pPr marL="0" indent="0">
               <a:buNone/>
             </a:pPr>
             <a:r>
@@ -6667,7 +6700,7 @@
           <a:bodyPr wrap="square" rtlCol="0" anchor="t"/>
           <a:lstStyle/>
           <a:p>
-            <a:pPr indent="0" marL="0">
+            <a:pPr marL="0" indent="0">
               <a:buNone/>
             </a:pPr>
             <a:endParaRPr lang="en-US" sz="600" dirty="0"/>
@@ -6693,6 +6726,13 @@
           </a:solidFill>
           <a:ln/>
         </p:spPr>
+        <p:txBody>
+          <a:bodyPr/>
+          <a:lstStyle/>
+          <a:p>
+            <a:endParaRPr lang="zh-TW" altLang="en-US"/>
+          </a:p>
+        </p:txBody>
       </p:sp>
       <p:sp>
         <p:nvSpPr>
@@ -6713,6 +6753,106 @@
           </a:solidFill>
           <a:ln/>
         </p:spPr>
+        <p:txBody>
+          <a:bodyPr/>
+          <a:lstStyle/>
+          <a:p>
+            <a:endParaRPr lang="zh-TW" altLang="en-US"/>
+          </a:p>
+        </p:txBody>
+      </p:sp>
+      <p:sp>
+        <p:nvSpPr>
+          <p:cNvPr id="52" name="Text 26">
+            <a:extLst>
+              <a:ext uri="{FF2B5EF4-FFF2-40B4-BE49-F238E27FC236}">
+                <a16:creationId xmlns:a16="http://schemas.microsoft.com/office/drawing/2014/main" id="{A7386244-57B8-9CC8-EB51-92E41E8B0E7A}"/>
+              </a:ext>
+            </a:extLst>
+          </p:cNvPr>
+          <p:cNvSpPr/>
+          <p:nvPr/>
+        </p:nvSpPr>
+        <p:spPr>
+          <a:xfrm>
+            <a:off x="7571232" y="2987802"/>
+            <a:ext cx="1828800" cy="219456"/>
+          </a:xfrm>
+          <a:prstGeom prst="rect">
+            <a:avLst/>
+          </a:prstGeom>
+          <a:noFill/>
+          <a:ln/>
+        </p:spPr>
+        <p:txBody>
+          <a:bodyPr wrap="square" rtlCol="0" anchor="ctr"/>
+          <a:lstStyle/>
+          <a:p>
+            <a:pPr marL="0" indent="0">
+              <a:buNone/>
+            </a:pPr>
+            <a:r>
+              <a:rPr lang="zh-TW" altLang="en-US" sz="1000" b="1" dirty="0">
+                <a:solidFill>
+                  <a:schemeClr val="tx1">
+                    <a:lumMod val="50000"/>
+                    <a:lumOff val="50000"/>
+                  </a:schemeClr>
+                </a:solidFill>
+                <a:latin typeface="Noto Sans TC" pitchFamily="34" charset="0"/>
+                <a:ea typeface="Noto Sans TC" pitchFamily="34" charset="-122"/>
+              </a:rPr>
+              <a:t>收瓶機*</a:t>
+            </a:r>
+            <a:r>
+              <a:rPr lang="en-US" altLang="zh-TW" sz="1000" b="1" dirty="0">
+                <a:solidFill>
+                  <a:schemeClr val="tx1">
+                    <a:lumMod val="50000"/>
+                    <a:lumOff val="50000"/>
+                  </a:schemeClr>
+                </a:solidFill>
+                <a:latin typeface="Noto Sans TC" pitchFamily="34" charset="0"/>
+                <a:ea typeface="Noto Sans TC" pitchFamily="34" charset="-122"/>
+              </a:rPr>
+              <a:t>43 &amp; </a:t>
+            </a:r>
+            <a:r>
+              <a:rPr lang="zh-TW" altLang="en-US" sz="1000" b="1" dirty="0">
+                <a:solidFill>
+                  <a:schemeClr val="tx1">
+                    <a:lumMod val="50000"/>
+                    <a:lumOff val="50000"/>
+                  </a:schemeClr>
+                </a:solidFill>
+                <a:latin typeface="Noto Sans TC" pitchFamily="34" charset="0"/>
+                <a:ea typeface="Noto Sans TC" pitchFamily="34" charset="-122"/>
+              </a:rPr>
+              <a:t>電池機*</a:t>
+            </a:r>
+            <a:r>
+              <a:rPr lang="en-US" altLang="zh-TW" sz="1000" b="1" dirty="0">
+                <a:solidFill>
+                  <a:schemeClr val="tx1">
+                    <a:lumMod val="50000"/>
+                    <a:lumOff val="50000"/>
+                  </a:schemeClr>
+                </a:solidFill>
+                <a:latin typeface="Noto Sans TC" pitchFamily="34" charset="0"/>
+                <a:ea typeface="Noto Sans TC" pitchFamily="34" charset="-122"/>
+              </a:rPr>
+              <a:t>2</a:t>
+            </a:r>
+            <a:endParaRPr lang="en-US" sz="1000" dirty="0">
+              <a:solidFill>
+                <a:schemeClr val="tx1">
+                  <a:lumMod val="50000"/>
+                  <a:lumOff val="50000"/>
+                </a:schemeClr>
+              </a:solidFill>
+            </a:endParaRPr>
+          </a:p>
+        </p:txBody>
       </p:sp>
     </p:spTree>
   </p:cSld>
@@ -6730,6 +6870,7 @@
         <a:solidFill>
           <a:srgbClr val="FFFFFF"/>
         </a:solidFill>
+        <a:effectLst/>
       </p:bgPr>
     </p:bg>
     <p:spTree>
@@ -6767,7 +6908,7 @@
           <a:bodyPr wrap="square" rtlCol="0" anchor="ctr"/>
           <a:lstStyle/>
           <a:p>
-            <a:pPr indent="0" marL="0">
+            <a:pPr marL="0" indent="0">
               <a:buNone/>
             </a:pPr>
             <a:r>
@@ -6804,6 +6945,13 @@
           </a:solidFill>
           <a:ln/>
         </p:spPr>
+        <p:txBody>
+          <a:bodyPr/>
+          <a:lstStyle/>
+          <a:p>
+            <a:endParaRPr lang="zh-TW" altLang="en-US"/>
+          </a:p>
+        </p:txBody>
       </p:sp>
       <p:sp>
         <p:nvSpPr>
@@ -6826,7 +6974,7 @@
           <a:bodyPr wrap="square" rtlCol="0" anchor="ctr"/>
           <a:lstStyle/>
           <a:p>
-            <a:pPr indent="0" marL="0">
+            <a:pPr marL="0" indent="0">
               <a:buNone/>
             </a:pPr>
             <a:r>
@@ -6846,7 +6994,7 @@
       </p:sp>
       <p:graphicFrame>
         <p:nvGraphicFramePr>
-          <p:cNvPr id="5" name="Chart 0" descr=""/>
+          <p:cNvPr id="5" name="Chart 0"/>
           <p:cNvGraphicFramePr/>
           <p:nvPr/>
         </p:nvGraphicFramePr>
@@ -6854,9 +7002,9 @@
           <a:off x="64008" y="475488"/>
           <a:ext cx="2788920" cy="1554480"/>
         </p:xfrm>
-        <a:graphic xmlns:a="http://schemas.openxmlformats.org/drawingml/2006/main">
+        <a:graphic>
           <a:graphicData uri="http://schemas.openxmlformats.org/drawingml/2006/chart">
-            <c:chart xmlns:c="http://schemas.openxmlformats.org/drawingml/2006/chart" r:id="rId1"/>
+            <c:chart xmlns:c="http://schemas.openxmlformats.org/drawingml/2006/chart" xmlns:r="http://schemas.openxmlformats.org/officeDocument/2006/relationships" r:id="rId3"/>
           </a:graphicData>
         </a:graphic>
       </p:graphicFrame>
@@ -6879,6 +7027,13 @@
           </a:solidFill>
           <a:ln/>
         </p:spPr>
+        <p:txBody>
+          <a:bodyPr/>
+          <a:lstStyle/>
+          <a:p>
+            <a:endParaRPr lang="zh-TW" altLang="en-US"/>
+          </a:p>
+        </p:txBody>
       </p:sp>
       <p:sp>
         <p:nvSpPr>
@@ -6901,7 +7056,7 @@
           <a:bodyPr wrap="square" rtlCol="0" anchor="ctr"/>
           <a:lstStyle/>
           <a:p>
-            <a:pPr indent="0" marL="0">
+            <a:pPr marL="0" indent="0">
               <a:buNone/>
             </a:pPr>
             <a:r>
@@ -6938,6 +7093,13 @@
           </a:solidFill>
           <a:ln/>
         </p:spPr>
+        <p:txBody>
+          <a:bodyPr/>
+          <a:lstStyle/>
+          <a:p>
+            <a:endParaRPr lang="zh-TW" altLang="en-US"/>
+          </a:p>
+        </p:txBody>
       </p:sp>
       <p:sp>
         <p:nvSpPr>
@@ -6960,7 +7122,7 @@
           <a:bodyPr wrap="square" rtlCol="0" anchor="ctr"/>
           <a:lstStyle/>
           <a:p>
-            <a:pPr indent="0" marL="0">
+            <a:pPr marL="0" indent="0">
               <a:buNone/>
             </a:pPr>
             <a:r>
@@ -6997,6 +7159,13 @@
           </a:solidFill>
           <a:ln/>
         </p:spPr>
+        <p:txBody>
+          <a:bodyPr/>
+          <a:lstStyle/>
+          <a:p>
+            <a:endParaRPr lang="zh-TW" altLang="en-US"/>
+          </a:p>
+        </p:txBody>
       </p:sp>
       <p:sp>
         <p:nvSpPr>
@@ -7019,7 +7188,7 @@
           <a:bodyPr wrap="square" rtlCol="0" anchor="ctr"/>
           <a:lstStyle/>
           <a:p>
-            <a:pPr indent="0" marL="0">
+            <a:pPr marL="0" indent="0">
               <a:buNone/>
             </a:pPr>
             <a:r>
@@ -7056,6 +7225,13 @@
           </a:solidFill>
           <a:ln/>
         </p:spPr>
+        <p:txBody>
+          <a:bodyPr/>
+          <a:lstStyle/>
+          <a:p>
+            <a:endParaRPr lang="zh-TW" altLang="en-US"/>
+          </a:p>
+        </p:txBody>
       </p:sp>
       <p:sp>
         <p:nvSpPr>
@@ -7078,7 +7254,7 @@
           <a:bodyPr wrap="square" rtlCol="0" anchor="ctr"/>
           <a:lstStyle/>
           <a:p>
-            <a:pPr indent="0" marL="0">
+            <a:pPr marL="0" indent="0">
               <a:buNone/>
             </a:pPr>
             <a:r>
@@ -7115,6 +7291,13 @@
           </a:solidFill>
           <a:ln/>
         </p:spPr>
+        <p:txBody>
+          <a:bodyPr/>
+          <a:lstStyle/>
+          <a:p>
+            <a:endParaRPr lang="zh-TW" altLang="en-US"/>
+          </a:p>
+        </p:txBody>
       </p:sp>
       <p:sp>
         <p:nvSpPr>
@@ -7137,7 +7320,7 @@
           <a:bodyPr wrap="square" rtlCol="0" anchor="ctr"/>
           <a:lstStyle/>
           <a:p>
-            <a:pPr indent="0" marL="0">
+            <a:pPr marL="0" indent="0">
               <a:buNone/>
             </a:pPr>
             <a:r>
@@ -7174,6 +7357,13 @@
           </a:solidFill>
           <a:ln/>
         </p:spPr>
+        <p:txBody>
+          <a:bodyPr/>
+          <a:lstStyle/>
+          <a:p>
+            <a:endParaRPr lang="zh-TW" altLang="en-US"/>
+          </a:p>
+        </p:txBody>
       </p:sp>
       <p:sp>
         <p:nvSpPr>
@@ -7196,7 +7386,7 @@
           <a:bodyPr wrap="square" rtlCol="0" anchor="ctr"/>
           <a:lstStyle/>
           <a:p>
-            <a:pPr indent="0" marL="0">
+            <a:pPr marL="0" indent="0">
               <a:buNone/>
             </a:pPr>
             <a:r>
@@ -7238,6 +7428,13 @@
             <a:prstDash val="solid"/>
           </a:ln>
         </p:spPr>
+        <p:txBody>
+          <a:bodyPr/>
+          <a:lstStyle/>
+          <a:p>
+            <a:endParaRPr lang="zh-TW" altLang="en-US"/>
+          </a:p>
+        </p:txBody>
       </p:sp>
       <p:sp>
         <p:nvSpPr>
@@ -7260,7 +7457,7 @@
           <a:bodyPr wrap="square" rtlCol="0" anchor="ctr"/>
           <a:lstStyle/>
           <a:p>
-            <a:pPr algn="ctr" indent="0" marL="0">
+            <a:pPr marL="0" indent="0" algn="ctr">
               <a:buNone/>
             </a:pPr>
             <a:r>
@@ -7299,7 +7496,7 @@
           <a:bodyPr wrap="square" rtlCol="0" anchor="ctr"/>
           <a:lstStyle/>
           <a:p>
-            <a:pPr algn="ctr" indent="0" marL="0">
+            <a:pPr marL="0" indent="0" algn="ctr">
               <a:buNone/>
             </a:pPr>
             <a:r>
@@ -7338,7 +7535,7 @@
           <a:bodyPr wrap="square" rtlCol="0" anchor="ctr"/>
           <a:lstStyle/>
           <a:p>
-            <a:pPr algn="ctr" indent="0" marL="0">
+            <a:pPr marL="0" indent="0" algn="ctr">
               <a:buNone/>
             </a:pPr>
             <a:r>
@@ -7380,6 +7577,13 @@
             <a:prstDash val="solid"/>
           </a:ln>
         </p:spPr>
+        <p:txBody>
+          <a:bodyPr/>
+          <a:lstStyle/>
+          <a:p>
+            <a:endParaRPr lang="zh-TW" altLang="en-US"/>
+          </a:p>
+        </p:txBody>
       </p:sp>
       <p:sp>
         <p:nvSpPr>
@@ -7402,7 +7606,7 @@
           <a:bodyPr wrap="square" rtlCol="0" anchor="ctr"/>
           <a:lstStyle/>
           <a:p>
-            <a:pPr algn="ctr" indent="0" marL="0">
+            <a:pPr marL="0" indent="0" algn="ctr">
               <a:buNone/>
             </a:pPr>
             <a:r>
@@ -7441,7 +7645,7 @@
           <a:bodyPr wrap="square" rtlCol="0" anchor="ctr"/>
           <a:lstStyle/>
           <a:p>
-            <a:pPr algn="ctr" indent="0" marL="0">
+            <a:pPr marL="0" indent="0" algn="ctr">
               <a:buNone/>
             </a:pPr>
             <a:r>
@@ -7480,7 +7684,7 @@
           <a:bodyPr wrap="square" rtlCol="0" anchor="ctr"/>
           <a:lstStyle/>
           <a:p>
-            <a:pPr algn="ctr" indent="0" marL="0">
+            <a:pPr marL="0" indent="0" algn="ctr">
               <a:buNone/>
             </a:pPr>
             <a:r>
@@ -7517,6 +7721,13 @@
           </a:solidFill>
           <a:ln/>
         </p:spPr>
+        <p:txBody>
+          <a:bodyPr/>
+          <a:lstStyle/>
+          <a:p>
+            <a:endParaRPr lang="zh-TW" altLang="en-US"/>
+          </a:p>
+        </p:txBody>
       </p:sp>
       <p:sp>
         <p:nvSpPr>
@@ -7539,7 +7750,7 @@
           <a:bodyPr wrap="square" rtlCol="0" anchor="ctr"/>
           <a:lstStyle/>
           <a:p>
-            <a:pPr indent="0" marL="0">
+            <a:pPr marL="0" indent="0">
               <a:buNone/>
             </a:pPr>
             <a:r>
@@ -7576,6 +7787,13 @@
           </a:solidFill>
           <a:ln/>
         </p:spPr>
+        <p:txBody>
+          <a:bodyPr/>
+          <a:lstStyle/>
+          <a:p>
+            <a:endParaRPr lang="zh-TW" altLang="en-US"/>
+          </a:p>
+        </p:txBody>
       </p:sp>
       <p:sp>
         <p:nvSpPr>
@@ -7598,7 +7816,7 @@
           <a:bodyPr wrap="square" rtlCol="0" anchor="ctr"/>
           <a:lstStyle/>
           <a:p>
-            <a:pPr indent="0" marL="0">
+            <a:pPr marL="0" indent="0">
               <a:buNone/>
             </a:pPr>
             <a:r>
@@ -7635,6 +7853,13 @@
           </a:solidFill>
           <a:ln/>
         </p:spPr>
+        <p:txBody>
+          <a:bodyPr/>
+          <a:lstStyle/>
+          <a:p>
+            <a:endParaRPr lang="zh-TW" altLang="en-US"/>
+          </a:p>
+        </p:txBody>
       </p:sp>
       <p:sp>
         <p:nvSpPr>
@@ -7657,7 +7882,7 @@
           <a:bodyPr wrap="square" rtlCol="0" anchor="ctr"/>
           <a:lstStyle/>
           <a:p>
-            <a:pPr algn="ctr" indent="0" marL="0">
+            <a:pPr marL="0" indent="0" algn="ctr">
               <a:buNone/>
             </a:pPr>
             <a:r>
@@ -7674,7 +7899,7 @@
             <a:endParaRPr lang="en-US" sz="1050" dirty="0"/>
           </a:p>
           <a:p>
-            <a:pPr algn="ctr" indent="0" marL="0">
+            <a:pPr marL="0" indent="0" algn="ctr">
               <a:buNone/>
             </a:pPr>
             <a:r>
@@ -7691,7 +7916,7 @@
             <a:endParaRPr lang="en-US" sz="1050" dirty="0"/>
           </a:p>
           <a:p>
-            <a:pPr algn="ctr" indent="0" marL="0">
+            <a:pPr marL="0" indent="0" algn="ctr">
               <a:buNone/>
             </a:pPr>
             <a:r>
@@ -7733,6 +7958,13 @@
             <a:prstDash val="solid"/>
           </a:ln>
         </p:spPr>
+        <p:txBody>
+          <a:bodyPr/>
+          <a:lstStyle/>
+          <a:p>
+            <a:endParaRPr lang="zh-TW" altLang="en-US"/>
+          </a:p>
+        </p:txBody>
       </p:sp>
       <p:sp>
         <p:nvSpPr>
@@ -7755,7 +7987,7 @@
           <a:bodyPr wrap="square" rtlCol="0" anchor="ctr"/>
           <a:lstStyle/>
           <a:p>
-            <a:pPr indent="0" marL="0">
+            <a:pPr marL="0" indent="0">
               <a:buNone/>
             </a:pPr>
             <a:r>
@@ -7794,7 +8026,7 @@
           <a:bodyPr wrap="square" rtlCol="0" anchor="ctr"/>
           <a:lstStyle/>
           <a:p>
-            <a:pPr indent="0" marL="0">
+            <a:pPr marL="0" indent="0">
               <a:buNone/>
             </a:pPr>
             <a:r>
@@ -7833,7 +8065,7 @@
           <a:bodyPr wrap="square" rtlCol="0" anchor="ctr"/>
           <a:lstStyle/>
           <a:p>
-            <a:pPr algn="r" indent="0" marL="0">
+            <a:pPr marL="0" indent="0" algn="r">
               <a:buNone/>
             </a:pPr>
             <a:r>
@@ -7870,6 +8102,13 @@
           </a:solidFill>
           <a:ln/>
         </p:spPr>
+        <p:txBody>
+          <a:bodyPr/>
+          <a:lstStyle/>
+          <a:p>
+            <a:endParaRPr lang="zh-TW" altLang="en-US"/>
+          </a:p>
+        </p:txBody>
       </p:sp>
       <p:sp>
         <p:nvSpPr>
@@ -7890,6 +8129,13 @@
           </a:solidFill>
           <a:ln/>
         </p:spPr>
+        <p:txBody>
+          <a:bodyPr/>
+          <a:lstStyle/>
+          <a:p>
+            <a:endParaRPr lang="zh-TW" altLang="en-US"/>
+          </a:p>
+        </p:txBody>
       </p:sp>
       <p:sp>
         <p:nvSpPr>
@@ -7915,6 +8161,13 @@
             <a:prstDash val="solid"/>
           </a:ln>
         </p:spPr>
+        <p:txBody>
+          <a:bodyPr/>
+          <a:lstStyle/>
+          <a:p>
+            <a:endParaRPr lang="zh-TW" altLang="en-US"/>
+          </a:p>
+        </p:txBody>
       </p:sp>
       <p:sp>
         <p:nvSpPr>
@@ -7937,7 +8190,7 @@
           <a:bodyPr wrap="square" rtlCol="0" anchor="ctr"/>
           <a:lstStyle/>
           <a:p>
-            <a:pPr indent="0" marL="0">
+            <a:pPr marL="0" indent="0">
               <a:buNone/>
             </a:pPr>
             <a:r>
@@ -7976,7 +8229,7 @@
           <a:bodyPr wrap="square" rtlCol="0" anchor="ctr"/>
           <a:lstStyle/>
           <a:p>
-            <a:pPr indent="0" marL="0">
+            <a:pPr marL="0" indent="0">
               <a:buNone/>
             </a:pPr>
             <a:r>
@@ -8015,7 +8268,7 @@
           <a:bodyPr wrap="square" rtlCol="0" anchor="ctr"/>
           <a:lstStyle/>
           <a:p>
-            <a:pPr algn="r" indent="0" marL="0">
+            <a:pPr marL="0" indent="0" algn="r">
               <a:buNone/>
             </a:pPr>
             <a:r>
@@ -8052,6 +8305,13 @@
           </a:solidFill>
           <a:ln/>
         </p:spPr>
+        <p:txBody>
+          <a:bodyPr/>
+          <a:lstStyle/>
+          <a:p>
+            <a:endParaRPr lang="zh-TW" altLang="en-US"/>
+          </a:p>
+        </p:txBody>
       </p:sp>
       <p:sp>
         <p:nvSpPr>
@@ -8072,6 +8332,13 @@
           </a:solidFill>
           <a:ln/>
         </p:spPr>
+        <p:txBody>
+          <a:bodyPr/>
+          <a:lstStyle/>
+          <a:p>
+            <a:endParaRPr lang="zh-TW" altLang="en-US"/>
+          </a:p>
+        </p:txBody>
       </p:sp>
       <p:sp>
         <p:nvSpPr>
@@ -8097,6 +8364,13 @@
             <a:prstDash val="solid"/>
           </a:ln>
         </p:spPr>
+        <p:txBody>
+          <a:bodyPr/>
+          <a:lstStyle/>
+          <a:p>
+            <a:endParaRPr lang="zh-TW" altLang="en-US"/>
+          </a:p>
+        </p:txBody>
       </p:sp>
       <p:sp>
         <p:nvSpPr>
@@ -8119,7 +8393,7 @@
           <a:bodyPr wrap="square" rtlCol="0" anchor="ctr"/>
           <a:lstStyle/>
           <a:p>
-            <a:pPr indent="0" marL="0">
+            <a:pPr marL="0" indent="0">
               <a:buNone/>
             </a:pPr>
             <a:r>
@@ -8158,7 +8432,7 @@
           <a:bodyPr wrap="square" rtlCol="0" anchor="ctr"/>
           <a:lstStyle/>
           <a:p>
-            <a:pPr indent="0" marL="0">
+            <a:pPr marL="0" indent="0">
               <a:buNone/>
             </a:pPr>
             <a:r>
@@ -8197,7 +8471,7 @@
           <a:bodyPr wrap="square" rtlCol="0" anchor="ctr"/>
           <a:lstStyle/>
           <a:p>
-            <a:pPr algn="r" indent="0" marL="0">
+            <a:pPr marL="0" indent="0" algn="r">
               <a:buNone/>
             </a:pPr>
             <a:r>
@@ -8234,6 +8508,13 @@
           </a:solidFill>
           <a:ln/>
         </p:spPr>
+        <p:txBody>
+          <a:bodyPr/>
+          <a:lstStyle/>
+          <a:p>
+            <a:endParaRPr lang="zh-TW" altLang="en-US"/>
+          </a:p>
+        </p:txBody>
       </p:sp>
       <p:sp>
         <p:nvSpPr>
@@ -8254,6 +8535,13 @@
           </a:solidFill>
           <a:ln/>
         </p:spPr>
+        <p:txBody>
+          <a:bodyPr/>
+          <a:lstStyle/>
+          <a:p>
+            <a:endParaRPr lang="zh-TW" altLang="en-US"/>
+          </a:p>
+        </p:txBody>
       </p:sp>
       <p:sp>
         <p:nvSpPr>
@@ -8274,6 +8562,13 @@
           </a:solidFill>
           <a:ln/>
         </p:spPr>
+        <p:txBody>
+          <a:bodyPr/>
+          <a:lstStyle/>
+          <a:p>
+            <a:endParaRPr lang="zh-TW" altLang="en-US"/>
+          </a:p>
+        </p:txBody>
       </p:sp>
       <p:sp>
         <p:nvSpPr>
@@ -8296,7 +8591,7 @@
           <a:bodyPr wrap="square" rtlCol="0" anchor="ctr"/>
           <a:lstStyle/>
           <a:p>
-            <a:pPr algn="ctr" indent="0" marL="0">
+            <a:pPr marL="0" indent="0" algn="ctr">
               <a:buNone/>
             </a:pPr>
             <a:r>
@@ -8313,7 +8608,7 @@
             <a:endParaRPr lang="en-US" sz="1050" dirty="0"/>
           </a:p>
           <a:p>
-            <a:pPr algn="ctr" indent="0" marL="0">
+            <a:pPr marL="0" indent="0" algn="ctr">
               <a:buNone/>
             </a:pPr>
             <a:r>
@@ -8330,7 +8625,7 @@
             <a:endParaRPr lang="en-US" sz="1050" dirty="0"/>
           </a:p>
           <a:p>
-            <a:pPr algn="ctr" indent="0" marL="0">
+            <a:pPr marL="0" indent="0" algn="ctr">
               <a:buNone/>
             </a:pPr>
             <a:r>
@@ -8372,6 +8667,13 @@
             <a:prstDash val="solid"/>
           </a:ln>
         </p:spPr>
+        <p:txBody>
+          <a:bodyPr/>
+          <a:lstStyle/>
+          <a:p>
+            <a:endParaRPr lang="zh-TW" altLang="en-US"/>
+          </a:p>
+        </p:txBody>
       </p:sp>
       <p:sp>
         <p:nvSpPr>
@@ -8394,7 +8696,7 @@
           <a:bodyPr wrap="square" rtlCol="0" anchor="ctr"/>
           <a:lstStyle/>
           <a:p>
-            <a:pPr indent="0" marL="0">
+            <a:pPr marL="0" indent="0">
               <a:buNone/>
             </a:pPr>
             <a:r>
@@ -8433,7 +8735,7 @@
           <a:bodyPr wrap="square" rtlCol="0" anchor="ctr"/>
           <a:lstStyle/>
           <a:p>
-            <a:pPr indent="0" marL="0">
+            <a:pPr marL="0" indent="0">
               <a:buNone/>
             </a:pPr>
             <a:r>
@@ -8472,7 +8774,7 @@
           <a:bodyPr wrap="square" rtlCol="0" anchor="ctr"/>
           <a:lstStyle/>
           <a:p>
-            <a:pPr algn="r" indent="0" marL="0">
+            <a:pPr marL="0" indent="0" algn="r">
               <a:buNone/>
             </a:pPr>
             <a:r>
@@ -8509,6 +8811,13 @@
           </a:solidFill>
           <a:ln/>
         </p:spPr>
+        <p:txBody>
+          <a:bodyPr/>
+          <a:lstStyle/>
+          <a:p>
+            <a:endParaRPr lang="zh-TW" altLang="en-US"/>
+          </a:p>
+        </p:txBody>
       </p:sp>
       <p:sp>
         <p:nvSpPr>
@@ -8529,6 +8838,13 @@
           </a:solidFill>
           <a:ln/>
         </p:spPr>
+        <p:txBody>
+          <a:bodyPr/>
+          <a:lstStyle/>
+          <a:p>
+            <a:endParaRPr lang="zh-TW" altLang="en-US"/>
+          </a:p>
+        </p:txBody>
       </p:sp>
       <p:sp>
         <p:nvSpPr>
@@ -8554,6 +8870,13 @@
             <a:prstDash val="solid"/>
           </a:ln>
         </p:spPr>
+        <p:txBody>
+          <a:bodyPr/>
+          <a:lstStyle/>
+          <a:p>
+            <a:endParaRPr lang="zh-TW" altLang="en-US"/>
+          </a:p>
+        </p:txBody>
       </p:sp>
       <p:sp>
         <p:nvSpPr>
@@ -8576,7 +8899,7 @@
           <a:bodyPr wrap="square" rtlCol="0" anchor="ctr"/>
           <a:lstStyle/>
           <a:p>
-            <a:pPr indent="0" marL="0">
+            <a:pPr marL="0" indent="0">
               <a:buNone/>
             </a:pPr>
             <a:r>
@@ -8615,7 +8938,7 @@
           <a:bodyPr wrap="square" rtlCol="0" anchor="ctr"/>
           <a:lstStyle/>
           <a:p>
-            <a:pPr indent="0" marL="0">
+            <a:pPr marL="0" indent="0">
               <a:buNone/>
             </a:pPr>
             <a:r>
@@ -8654,7 +8977,7 @@
           <a:bodyPr wrap="square" rtlCol="0" anchor="ctr"/>
           <a:lstStyle/>
           <a:p>
-            <a:pPr algn="r" indent="0" marL="0">
+            <a:pPr marL="0" indent="0" algn="r">
               <a:buNone/>
             </a:pPr>
             <a:r>
@@ -8691,6 +9014,13 @@
           </a:solidFill>
           <a:ln/>
         </p:spPr>
+        <p:txBody>
+          <a:bodyPr/>
+          <a:lstStyle/>
+          <a:p>
+            <a:endParaRPr lang="zh-TW" altLang="en-US"/>
+          </a:p>
+        </p:txBody>
       </p:sp>
       <p:sp>
         <p:nvSpPr>
@@ -8711,6 +9041,13 @@
           </a:solidFill>
           <a:ln/>
         </p:spPr>
+        <p:txBody>
+          <a:bodyPr/>
+          <a:lstStyle/>
+          <a:p>
+            <a:endParaRPr lang="zh-TW" altLang="en-US"/>
+          </a:p>
+        </p:txBody>
       </p:sp>
       <p:sp>
         <p:nvSpPr>
@@ -8736,6 +9073,13 @@
             <a:prstDash val="solid"/>
           </a:ln>
         </p:spPr>
+        <p:txBody>
+          <a:bodyPr/>
+          <a:lstStyle/>
+          <a:p>
+            <a:endParaRPr lang="zh-TW" altLang="en-US"/>
+          </a:p>
+        </p:txBody>
       </p:sp>
       <p:sp>
         <p:nvSpPr>
@@ -8758,7 +9102,7 @@
           <a:bodyPr wrap="square" rtlCol="0" anchor="t"/>
           <a:lstStyle/>
           <a:p>
-            <a:pPr indent="0" marL="0">
+            <a:pPr marL="0" indent="0">
               <a:buNone/>
             </a:pPr>
             <a:r>
@@ -8795,6 +9139,13 @@
           </a:solidFill>
           <a:ln/>
         </p:spPr>
+        <p:txBody>
+          <a:bodyPr/>
+          <a:lstStyle/>
+          <a:p>
+            <a:endParaRPr lang="zh-TW" altLang="en-US"/>
+          </a:p>
+        </p:txBody>
       </p:sp>
       <p:sp>
         <p:nvSpPr>
@@ -8817,7 +9168,7 @@
           <a:bodyPr wrap="square" rtlCol="0" anchor="ctr"/>
           <a:lstStyle/>
           <a:p>
-            <a:pPr indent="0" marL="0">
+            <a:pPr marL="0" indent="0">
               <a:buNone/>
             </a:pPr>
             <a:r>
@@ -8856,7 +9207,7 @@
           <a:bodyPr wrap="square" rtlCol="0" anchor="ctr"/>
           <a:lstStyle/>
           <a:p>
-            <a:pPr algn="r" indent="0" marL="0">
+            <a:pPr marL="0" indent="0" algn="r">
               <a:buNone/>
             </a:pPr>
             <a:r>
@@ -8895,7 +9246,7 @@
           <a:bodyPr wrap="square" rtlCol="0" anchor="ctr"/>
           <a:lstStyle/>
           <a:p>
-            <a:pPr indent="0" marL="0">
+            <a:pPr marL="0" indent="0">
               <a:buNone/>
             </a:pPr>
             <a:r>
@@ -8934,7 +9285,7 @@
           <a:bodyPr wrap="square" rtlCol="0" anchor="ctr"/>
           <a:lstStyle/>
           <a:p>
-            <a:pPr algn="r" indent="0" marL="0">
+            <a:pPr marL="0" indent="0" algn="r">
               <a:buNone/>
             </a:pPr>
             <a:r>
@@ -8973,7 +9324,7 @@
           <a:bodyPr wrap="square" rtlCol="0" anchor="ctr"/>
           <a:lstStyle/>
           <a:p>
-            <a:pPr indent="0" marL="0">
+            <a:pPr marL="0" indent="0">
               <a:buNone/>
             </a:pPr>
             <a:r>
@@ -9012,7 +9363,7 @@
           <a:bodyPr wrap="square" rtlCol="0" anchor="ctr"/>
           <a:lstStyle/>
           <a:p>
-            <a:pPr algn="r" indent="0" marL="0">
+            <a:pPr marL="0" indent="0" algn="r">
               <a:buNone/>
             </a:pPr>
             <a:r>
@@ -9051,7 +9402,7 @@
           <a:bodyPr wrap="square" rtlCol="0" anchor="ctr"/>
           <a:lstStyle/>
           <a:p>
-            <a:pPr indent="0" marL="0">
+            <a:pPr marL="0" indent="0">
               <a:buNone/>
             </a:pPr>
             <a:r>
@@ -9090,7 +9441,7 @@
           <a:bodyPr wrap="square" rtlCol="0" anchor="ctr"/>
           <a:lstStyle/>
           <a:p>
-            <a:pPr algn="r" indent="0" marL="0">
+            <a:pPr marL="0" indent="0" algn="r">
               <a:buNone/>
             </a:pPr>
             <a:r>
@@ -9127,6 +9478,13 @@
           </a:solidFill>
           <a:ln/>
         </p:spPr>
+        <p:txBody>
+          <a:bodyPr/>
+          <a:lstStyle/>
+          <a:p>
+            <a:endParaRPr lang="zh-TW" altLang="en-US"/>
+          </a:p>
+        </p:txBody>
       </p:sp>
       <p:sp>
         <p:nvSpPr>
@@ -9149,7 +9507,7 @@
           <a:bodyPr wrap="square" rtlCol="0" anchor="ctr"/>
           <a:lstStyle/>
           <a:p>
-            <a:pPr indent="0" marL="0">
+            <a:pPr marL="0" indent="0">
               <a:buNone/>
             </a:pPr>
             <a:r>
@@ -9188,7 +9546,7 @@
           <a:bodyPr wrap="square" rtlCol="0" anchor="ctr"/>
           <a:lstStyle/>
           <a:p>
-            <a:pPr algn="r" indent="0" marL="0">
+            <a:pPr marL="0" indent="0" algn="r">
               <a:buNone/>
             </a:pPr>
             <a:r>
@@ -9227,7 +9585,7 @@
           <a:bodyPr wrap="square" rtlCol="0" anchor="ctr"/>
           <a:lstStyle/>
           <a:p>
-            <a:pPr indent="0" marL="0">
+            <a:pPr marL="0" indent="0">
               <a:buNone/>
             </a:pPr>
             <a:r>
@@ -9266,7 +9624,7 @@
           <a:bodyPr wrap="square" rtlCol="0" anchor="ctr"/>
           <a:lstStyle/>
           <a:p>
-            <a:pPr algn="r" indent="0" marL="0">
+            <a:pPr marL="0" indent="0" algn="r">
               <a:buNone/>
             </a:pPr>
             <a:r>
@@ -9305,7 +9663,7 @@
           <a:bodyPr wrap="square" rtlCol="0" anchor="ctr"/>
           <a:lstStyle/>
           <a:p>
-            <a:pPr indent="0" marL="0">
+            <a:pPr marL="0" indent="0">
               <a:buNone/>
             </a:pPr>
             <a:r>
@@ -9344,7 +9702,7 @@
           <a:bodyPr wrap="square" rtlCol="0" anchor="ctr"/>
           <a:lstStyle/>
           <a:p>
-            <a:pPr algn="r" indent="0" marL="0">
+            <a:pPr marL="0" indent="0" algn="r">
               <a:buNone/>
             </a:pPr>
             <a:r>
@@ -9383,7 +9741,7 @@
           <a:bodyPr wrap="square" rtlCol="0" anchor="ctr"/>
           <a:lstStyle/>
           <a:p>
-            <a:pPr indent="0" marL="0">
+            <a:pPr marL="0" indent="0">
               <a:buNone/>
             </a:pPr>
             <a:r>
@@ -9422,7 +9780,7 @@
           <a:bodyPr wrap="square" rtlCol="0" anchor="ctr"/>
           <a:lstStyle/>
           <a:p>
-            <a:pPr algn="r" indent="0" marL="0">
+            <a:pPr marL="0" indent="0" algn="r">
               <a:buNone/>
             </a:pPr>
             <a:r>
@@ -9459,6 +9817,13 @@
           </a:solidFill>
           <a:ln/>
         </p:spPr>
+        <p:txBody>
+          <a:bodyPr/>
+          <a:lstStyle/>
+          <a:p>
+            <a:endParaRPr lang="zh-TW" altLang="en-US"/>
+          </a:p>
+        </p:txBody>
       </p:sp>
       <p:sp>
         <p:nvSpPr>
@@ -9481,7 +9846,7 @@
           <a:bodyPr wrap="square" rtlCol="0" anchor="ctr"/>
           <a:lstStyle/>
           <a:p>
-            <a:pPr indent="0" marL="0">
+            <a:pPr marL="0" indent="0">
               <a:buNone/>
             </a:pPr>
             <a:r>
@@ -9520,7 +9885,7 @@
           <a:bodyPr wrap="square" rtlCol="0" anchor="ctr"/>
           <a:lstStyle/>
           <a:p>
-            <a:pPr algn="r" indent="0" marL="0">
+            <a:pPr marL="0" indent="0" algn="r">
               <a:buNone/>
             </a:pPr>
             <a:r>
@@ -9559,7 +9924,7 @@
           <a:bodyPr wrap="square" rtlCol="0" anchor="ctr"/>
           <a:lstStyle/>
           <a:p>
-            <a:pPr indent="0" marL="0">
+            <a:pPr marL="0" indent="0">
               <a:buNone/>
             </a:pPr>
             <a:r>
@@ -9598,7 +9963,7 @@
           <a:bodyPr wrap="square" rtlCol="0" anchor="ctr"/>
           <a:lstStyle/>
           <a:p>
-            <a:pPr algn="r" indent="0" marL="0">
+            <a:pPr marL="0" indent="0" algn="r">
               <a:buNone/>
             </a:pPr>
             <a:r>
@@ -9637,7 +10002,7 @@
           <a:bodyPr wrap="square" rtlCol="0" anchor="ctr"/>
           <a:lstStyle/>
           <a:p>
-            <a:pPr indent="0" marL="0">
+            <a:pPr marL="0" indent="0">
               <a:buNone/>
             </a:pPr>
             <a:r>
@@ -9676,7 +10041,7 @@
           <a:bodyPr wrap="square" rtlCol="0" anchor="ctr"/>
           <a:lstStyle/>
           <a:p>
-            <a:pPr algn="r" indent="0" marL="0">
+            <a:pPr marL="0" indent="0" algn="r">
               <a:buNone/>
             </a:pPr>
             <a:r>
@@ -9715,7 +10080,7 @@
           <a:bodyPr wrap="square" rtlCol="0" anchor="ctr"/>
           <a:lstStyle/>
           <a:p>
-            <a:pPr indent="0" marL="0">
+            <a:pPr marL="0" indent="0">
               <a:buNone/>
             </a:pPr>
             <a:r>
@@ -9754,7 +10119,7 @@
           <a:bodyPr wrap="square" rtlCol="0" anchor="ctr"/>
           <a:lstStyle/>
           <a:p>
-            <a:pPr algn="r" indent="0" marL="0">
+            <a:pPr marL="0" indent="0" algn="r">
               <a:buNone/>
             </a:pPr>
             <a:r>
@@ -10073,4 +10438,319 @@
     </a:ext>
   </a:extLst>
 </a:theme>
+</file>
+
+<file path=ppt/theme/theme2.xml><?xml version="1.0" encoding="utf-8"?>
+<a:theme xmlns:a="http://schemas.openxmlformats.org/drawingml/2006/main" name="Office 佈景主題">
+  <a:themeElements>
+    <a:clrScheme name="Office">
+      <a:dk1>
+        <a:sysClr val="windowText" lastClr="000000"/>
+      </a:dk1>
+      <a:lt1>
+        <a:sysClr val="window" lastClr="FFFFFF"/>
+      </a:lt1>
+      <a:dk2>
+        <a:srgbClr val="0E2841"/>
+      </a:dk2>
+      <a:lt2>
+        <a:srgbClr val="E8E8E8"/>
+      </a:lt2>
+      <a:accent1>
+        <a:srgbClr val="156082"/>
+      </a:accent1>
+      <a:accent2>
+        <a:srgbClr val="E97132"/>
+      </a:accent2>
+      <a:accent3>
+        <a:srgbClr val="196B24"/>
+      </a:accent3>
+      <a:accent4>
+        <a:srgbClr val="0F9ED5"/>
+      </a:accent4>
+      <a:accent5>
+        <a:srgbClr val="A02B93"/>
+      </a:accent5>
+      <a:accent6>
+        <a:srgbClr val="4EA72E"/>
+      </a:accent6>
+      <a:hlink>
+        <a:srgbClr val="467886"/>
+      </a:hlink>
+      <a:folHlink>
+        <a:srgbClr val="96607D"/>
+      </a:folHlink>
+    </a:clrScheme>
+    <a:fontScheme name="Office">
+      <a:majorFont>
+        <a:latin typeface="Aptos Display" panose="02110004020202020204"/>
+        <a:ea typeface=""/>
+        <a:cs typeface=""/>
+        <a:font script="Jpan" typeface="游ゴシック Light"/>
+        <a:font script="Hang" typeface="맑은 고딕"/>
+        <a:font script="Hans" typeface="等线 Light"/>
+        <a:font script="Hant" typeface="新細明體"/>
+        <a:font script="Arab" typeface="Times New Roman"/>
+        <a:font script="Hebr" typeface="Times New Roman"/>
+        <a:font script="Thai" typeface="Angsana New"/>
+        <a:font script="Ethi" typeface="Nyala"/>
+        <a:font script="Beng" typeface="Vrinda"/>
+        <a:font script="Gujr" typeface="Shruti"/>
+        <a:font script="Khmr" typeface="MoolBoran"/>
+        <a:font script="Knda" typeface="Tunga"/>
+        <a:font script="Guru" typeface="Raavi"/>
+        <a:font script="Cans" typeface="Euphemia"/>
+        <a:font script="Cher" typeface="Plantagenet Cherokee"/>
+        <a:font script="Yiii" typeface="Microsoft Yi Baiti"/>
+        <a:font script="Tibt" typeface="Microsoft Himalaya"/>
+        <a:font script="Thaa" typeface="MV Boli"/>
+        <a:font script="Deva" typeface="Mangal"/>
+        <a:font script="Telu" typeface="Gautami"/>
+        <a:font script="Taml" typeface="Latha"/>
+        <a:font script="Syrc" typeface="Estrangelo Edessa"/>
+        <a:font script="Orya" typeface="Kalinga"/>
+        <a:font script="Mlym" typeface="Kartika"/>
+        <a:font script="Laoo" typeface="DokChampa"/>
+        <a:font script="Sinh" typeface="Iskoola Pota"/>
+        <a:font script="Mong" typeface="Mongolian Baiti"/>
+        <a:font script="Viet" typeface="Times New Roman"/>
+        <a:font script="Uigh" typeface="Microsoft Uighur"/>
+        <a:font script="Geor" typeface="Sylfaen"/>
+        <a:font script="Armn" typeface="Arial"/>
+        <a:font script="Bugi" typeface="Leelawadee UI"/>
+        <a:font script="Bopo" typeface="Microsoft JhengHei"/>
+        <a:font script="Java" typeface="Javanese Text"/>
+        <a:font script="Lisu" typeface="Segoe UI"/>
+        <a:font script="Mymr" typeface="Myanmar Text"/>
+        <a:font script="Nkoo" typeface="Ebrima"/>
+        <a:font script="Olck" typeface="Nirmala UI"/>
+        <a:font script="Osma" typeface="Ebrima"/>
+        <a:font script="Phag" typeface="Phagspa"/>
+        <a:font script="Syrn" typeface="Estrangelo Edessa"/>
+        <a:font script="Syrj" typeface="Estrangelo Edessa"/>
+        <a:font script="Syre" typeface="Estrangelo Edessa"/>
+        <a:font script="Sora" typeface="Nirmala UI"/>
+        <a:font script="Tale" typeface="Microsoft Tai Le"/>
+        <a:font script="Talu" typeface="Microsoft New Tai Lue"/>
+        <a:font script="Tfng" typeface="Ebrima"/>
+      </a:majorFont>
+      <a:minorFont>
+        <a:latin typeface="Aptos" panose="02110004020202020204"/>
+        <a:ea typeface=""/>
+        <a:cs typeface=""/>
+        <a:font script="Jpan" typeface="游ゴシック"/>
+        <a:font script="Hang" typeface="맑은 고딕"/>
+        <a:font script="Hans" typeface="等线"/>
+        <a:font script="Hant" typeface="新細明體"/>
+        <a:font script="Arab" typeface="Arial"/>
+        <a:font script="Hebr" typeface="Arial"/>
+        <a:font script="Thai" typeface="Cordia New"/>
+        <a:font script="Ethi" typeface="Nyala"/>
+        <a:font script="Beng" typeface="Vrinda"/>
+        <a:font script="Gujr" typeface="Shruti"/>
+        <a:font script="Khmr" typeface="DaunPenh"/>
+        <a:font script="Knda" typeface="Tunga"/>
+        <a:font script="Guru" typeface="Raavi"/>
+        <a:font script="Cans" typeface="Euphemia"/>
+        <a:font script="Cher" typeface="Plantagenet Cherokee"/>
+        <a:font script="Yiii" typeface="Microsoft Yi Baiti"/>
+        <a:font script="Tibt" typeface="Microsoft Himalaya"/>
+        <a:font script="Thaa" typeface="MV Boli"/>
+        <a:font script="Deva" typeface="Mangal"/>
+        <a:font script="Telu" typeface="Gautami"/>
+        <a:font script="Taml" typeface="Latha"/>
+        <a:font script="Syrc" typeface="Estrangelo Edessa"/>
+        <a:font script="Orya" typeface="Kalinga"/>
+        <a:font script="Mlym" typeface="Kartika"/>
+        <a:font script="Laoo" typeface="DokChampa"/>
+        <a:font script="Sinh" typeface="Iskoola Pota"/>
+        <a:font script="Mong" typeface="Mongolian Baiti"/>
+        <a:font script="Viet" typeface="Arial"/>
+        <a:font script="Uigh" typeface="Microsoft Uighur"/>
+        <a:font script="Geor" typeface="Sylfaen"/>
+        <a:font script="Armn" typeface="Arial"/>
+        <a:font script="Bugi" typeface="Leelawadee UI"/>
+        <a:font script="Bopo" typeface="Microsoft JhengHei"/>
+        <a:font script="Java" typeface="Javanese Text"/>
+        <a:font script="Lisu" typeface="Segoe UI"/>
+        <a:font script="Mymr" typeface="Myanmar Text"/>
+        <a:font script="Nkoo" typeface="Ebrima"/>
+        <a:font script="Olck" typeface="Nirmala UI"/>
+        <a:font script="Osma" typeface="Ebrima"/>
+        <a:font script="Phag" typeface="Phagspa"/>
+        <a:font script="Syrn" typeface="Estrangelo Edessa"/>
+        <a:font script="Syrj" typeface="Estrangelo Edessa"/>
+        <a:font script="Syre" typeface="Estrangelo Edessa"/>
+        <a:font script="Sora" typeface="Nirmala UI"/>
+        <a:font script="Tale" typeface="Microsoft Tai Le"/>
+        <a:font script="Talu" typeface="Microsoft New Tai Lue"/>
+        <a:font script="Tfng" typeface="Ebrima"/>
+      </a:minorFont>
+    </a:fontScheme>
+    <a:fmtScheme name="Office">
+      <a:fillStyleLst>
+        <a:solidFill>
+          <a:schemeClr val="phClr"/>
+        </a:solidFill>
+        <a:gradFill rotWithShape="1">
+          <a:gsLst>
+            <a:gs pos="0">
+              <a:schemeClr val="phClr">
+                <a:lumMod val="110000"/>
+                <a:satMod val="105000"/>
+                <a:tint val="67000"/>
+              </a:schemeClr>
+            </a:gs>
+            <a:gs pos="50000">
+              <a:schemeClr val="phClr">
+                <a:lumMod val="105000"/>
+                <a:satMod val="103000"/>
+                <a:tint val="73000"/>
+              </a:schemeClr>
+            </a:gs>
+            <a:gs pos="100000">
+              <a:schemeClr val="phClr">
+                <a:lumMod val="105000"/>
+                <a:satMod val="109000"/>
+                <a:tint val="81000"/>
+              </a:schemeClr>
+            </a:gs>
+          </a:gsLst>
+          <a:lin ang="5400000" scaled="0"/>
+        </a:gradFill>
+        <a:gradFill rotWithShape="1">
+          <a:gsLst>
+            <a:gs pos="0">
+              <a:schemeClr val="phClr">
+                <a:satMod val="103000"/>
+                <a:lumMod val="102000"/>
+                <a:tint val="94000"/>
+              </a:schemeClr>
+            </a:gs>
+            <a:gs pos="50000">
+              <a:schemeClr val="phClr">
+                <a:satMod val="110000"/>
+                <a:lumMod val="100000"/>
+                <a:shade val="100000"/>
+              </a:schemeClr>
+            </a:gs>
+            <a:gs pos="100000">
+              <a:schemeClr val="phClr">
+                <a:lumMod val="99000"/>
+                <a:satMod val="120000"/>
+                <a:shade val="78000"/>
+              </a:schemeClr>
+            </a:gs>
+          </a:gsLst>
+          <a:lin ang="5400000" scaled="0"/>
+        </a:gradFill>
+      </a:fillStyleLst>
+      <a:lnStyleLst>
+        <a:ln w="12700" cap="flat" cmpd="sng" algn="ctr">
+          <a:solidFill>
+            <a:schemeClr val="phClr"/>
+          </a:solidFill>
+          <a:prstDash val="solid"/>
+          <a:miter lim="800000"/>
+        </a:ln>
+        <a:ln w="19050" cap="flat" cmpd="sng" algn="ctr">
+          <a:solidFill>
+            <a:schemeClr val="phClr"/>
+          </a:solidFill>
+          <a:prstDash val="solid"/>
+          <a:miter lim="800000"/>
+        </a:ln>
+        <a:ln w="25400" cap="flat" cmpd="sng" algn="ctr">
+          <a:solidFill>
+            <a:schemeClr val="phClr"/>
+          </a:solidFill>
+          <a:prstDash val="solid"/>
+          <a:miter lim="800000"/>
+        </a:ln>
+      </a:lnStyleLst>
+      <a:effectStyleLst>
+        <a:effectStyle>
+          <a:effectLst/>
+        </a:effectStyle>
+        <a:effectStyle>
+          <a:effectLst/>
+        </a:effectStyle>
+        <a:effectStyle>
+          <a:effectLst>
+            <a:outerShdw blurRad="57150" dist="19050" dir="5400000" algn="ctr" rotWithShape="0">
+              <a:srgbClr val="000000">
+                <a:alpha val="63000"/>
+              </a:srgbClr>
+            </a:outerShdw>
+          </a:effectLst>
+        </a:effectStyle>
+      </a:effectStyleLst>
+      <a:bgFillStyleLst>
+        <a:solidFill>
+          <a:schemeClr val="phClr"/>
+        </a:solidFill>
+        <a:solidFill>
+          <a:schemeClr val="phClr">
+            <a:tint val="95000"/>
+            <a:satMod val="170000"/>
+          </a:schemeClr>
+        </a:solidFill>
+        <a:gradFill rotWithShape="1">
+          <a:gsLst>
+            <a:gs pos="0">
+              <a:schemeClr val="phClr">
+                <a:tint val="93000"/>
+                <a:satMod val="150000"/>
+                <a:shade val="98000"/>
+                <a:lumMod val="102000"/>
+              </a:schemeClr>
+            </a:gs>
+            <a:gs pos="50000">
+              <a:schemeClr val="phClr">
+                <a:tint val="98000"/>
+                <a:satMod val="130000"/>
+                <a:shade val="90000"/>
+                <a:lumMod val="103000"/>
+              </a:schemeClr>
+            </a:gs>
+            <a:gs pos="100000">
+              <a:schemeClr val="phClr">
+                <a:shade val="63000"/>
+                <a:satMod val="120000"/>
+              </a:schemeClr>
+            </a:gs>
+          </a:gsLst>
+          <a:lin ang="5400000" scaled="0"/>
+        </a:gradFill>
+      </a:bgFillStyleLst>
+    </a:fmtScheme>
+  </a:themeElements>
+  <a:objectDefaults>
+    <a:lnDef>
+      <a:spPr/>
+      <a:bodyPr/>
+      <a:lstStyle/>
+      <a:style>
+        <a:lnRef idx="2">
+          <a:schemeClr val="accent1"/>
+        </a:lnRef>
+        <a:fillRef idx="0">
+          <a:schemeClr val="accent1"/>
+        </a:fillRef>
+        <a:effectRef idx="1">
+          <a:schemeClr val="accent1"/>
+        </a:effectRef>
+        <a:fontRef idx="minor">
+          <a:schemeClr val="tx1"/>
+        </a:fontRef>
+      </a:style>
+    </a:lnDef>
+  </a:objectDefaults>
+  <a:extraClrSchemeLst/>
+  <a:extLst>
+    <a:ext uri="{05A4C25C-085E-4340-85A3-A5531E510DB2}">
+      <thm15:themeFamily xmlns:thm15="http://schemas.microsoft.com/office/thememl/2012/main" name="Office Theme" id="{2E142A2C-CD16-42D6-873A-C26D2A0506FA}" vid="{1BDDFF52-6CD6-40A5-AB3C-68EB2F1E4D0A}"/>
+    </a:ext>
+  </a:extLst>
+</a:theme>
 </file>
</xml_diff>